<commit_message>
vault backup: 2026-06-30 22:39:52
</commit_message>
<xml_diff>
--- a/50_Resources/GaussDB_openGauss_存储与缓存_源码讲解.pptx
+++ b/50_Resources/GaussDB_openGauss_存储与缓存_源码讲解.pptx
@@ -9,34 +9,34 @@
   </p:notesMasterIdLst>
   <p:sldIdLst>
     <p:sldId id="256" r:id="rId2"/>
-    <p:sldId id="257" r:id="rId3"/>
-    <p:sldId id="259" r:id="rId4"/>
-    <p:sldId id="260" r:id="rId5"/>
-    <p:sldId id="261" r:id="rId6"/>
-    <p:sldId id="262" r:id="rId7"/>
-    <p:sldId id="263" r:id="rId8"/>
-    <p:sldId id="264" r:id="rId9"/>
-    <p:sldId id="265" r:id="rId10"/>
-    <p:sldId id="266" r:id="rId11"/>
-    <p:sldId id="267" r:id="rId12"/>
-    <p:sldId id="268" r:id="rId13"/>
-    <p:sldId id="269" r:id="rId14"/>
-    <p:sldId id="270" r:id="rId15"/>
-    <p:sldId id="271" r:id="rId16"/>
-    <p:sldId id="272" r:id="rId17"/>
-    <p:sldId id="273" r:id="rId18"/>
-    <p:sldId id="274" r:id="rId19"/>
-    <p:sldId id="275" r:id="rId20"/>
-    <p:sldId id="276" r:id="rId21"/>
-    <p:sldId id="277" r:id="rId22"/>
-    <p:sldId id="278" r:id="rId23"/>
-    <p:sldId id="279" r:id="rId24"/>
-    <p:sldId id="280" r:id="rId25"/>
-    <p:sldId id="281" r:id="rId26"/>
-    <p:sldId id="282" r:id="rId27"/>
+    <p:sldId id="288" r:id="rId3"/>
+    <p:sldId id="289" r:id="rId4"/>
+    <p:sldId id="290" r:id="rId5"/>
+    <p:sldId id="291" r:id="rId6"/>
+    <p:sldId id="292" r:id="rId7"/>
+    <p:sldId id="293" r:id="rId8"/>
+    <p:sldId id="294" r:id="rId9"/>
+    <p:sldId id="295" r:id="rId10"/>
+    <p:sldId id="296" r:id="rId11"/>
+    <p:sldId id="297" r:id="rId12"/>
+    <p:sldId id="298" r:id="rId13"/>
+    <p:sldId id="299" r:id="rId14"/>
+    <p:sldId id="300" r:id="rId15"/>
+    <p:sldId id="301" r:id="rId16"/>
+    <p:sldId id="302" r:id="rId17"/>
+    <p:sldId id="303" r:id="rId18"/>
+    <p:sldId id="304" r:id="rId19"/>
+    <p:sldId id="305" r:id="rId20"/>
+    <p:sldId id="306" r:id="rId21"/>
+    <p:sldId id="307" r:id="rId22"/>
+    <p:sldId id="308" r:id="rId23"/>
+    <p:sldId id="309" r:id="rId24"/>
+    <p:sldId id="310" r:id="rId25"/>
+    <p:sldId id="311" r:id="rId26"/>
+    <p:sldId id="312" r:id="rId27"/>
     <p:sldId id="287" r:id="rId28"/>
-    <p:sldId id="284" r:id="rId29"/>
-    <p:sldId id="285" r:id="rId30"/>
+    <p:sldId id="313" r:id="rId29"/>
+    <p:sldId id="314" r:id="rId30"/>
   </p:sldIdLst>
   <p:sldSz cx="12192000" cy="6858000"/>
   <p:notesSz cx="6858000" cy="9144000"/>
@@ -392,22 +392,26 @@
           <a:lstStyle/>
           <a:p>
             <a:r>
-              <a:t>FlushBuffer 是把一个脏页真正写到磁盘的统一出口。第 5196 行先用 StartBufferIO 抢到该 buffer 的 io_in_progress 状态，如果别人已经先刷了它就直接 return，避免重复写。注意写盘只需要页面的"共享内容锁"——因为别的会话此刻可能仍在改 hint bit，所以做 checksum 时会把页拷一份到私有内存（PageSetChecksumCopy）。</a:t>
-            </a:r>
-          </a:p>
-          <a:p>
-            <a:r>
-              <a:t>第 5234 行的 XLogWaitFlush 是 WAL 铁律的落地：数据页落盘前，必须先把描述这次修改的 redo 日志刷到磁盘（page LSN 之前的日志），否则崩溃后无法重放。</a:t>
-            </a:r>
-          </a:p>
-          <a:p>
-            <a:r>
-              <a:t>真正的写动作在 5333 行 smgrwrite，经存储管理器写入数据文件；skipFsync 决定是否把 fsync 推迟交给后续 checkpoint 统一做（提升吞吐）。段页式表走的是上面的 seg_physical_write 分支，不是这里。</a:t>
-            </a:r>
-          </a:p>
-          <a:p>
-            <a:r>
-              <a:t>这个函数被 SyncOneBuffer(bufmgr.cpp:4703) 调用，而 SyncOneBuffer 同时被后台写线程 bgwriter 与检查点/pagewriter 共用——同一段刷盘逻辑，三条上游路径复用。</a:t>
+              <a:rPr lang="zh-CN" dirty="0"/>
+              <a:t>FlushBuffer 是脏页写盘的统一出口。先 StartBufferIO 抢到这页的 io_in_progress 状态;如果别人已经在刷,直接返回,避免重复写。写盘只需共享内容锁——此刻别的会话还可能在改 hint bit,所以算 checksum 时用 PageSetChecksumCopy 把页拷一份到私有内存。</a:t>
+            </a:r>
+          </a:p>
+          <a:p>
+            <a:r>
+              <a:rPr lang="zh-CN" dirty="0"/>
+              <a:t>接着 XLogWaitFlush 落实 WAL 铁律:数据页落盘前,必须先把这次修改对应的 redo 日志(page LSN 之前的)刷到磁盘,否则崩溃后没法重放。</a:t>
+            </a:r>
+          </a:p>
+          <a:p>
+            <a:r>
+              <a:rPr lang="zh-CN" dirty="0"/>
+              <a:t>真正的写在 smgrwrite,经存储管理器写进数据文件;skipFsync 决定要不要把 fsync 推迟给检查点统一做以提吞吐。段页式表走 seg_physical_write 分支,不在这里。</a:t>
+            </a:r>
+          </a:p>
+          <a:p>
+            <a:r>
+              <a:rPr lang="zh-CN" dirty="0"/>
+              <a:t>串起来看:这个函数由 SyncOneBuffer 调用,而 SyncOneBuffer 被 bgwriter、检查点/pagewriter 三条上游共用——同一段刷盘逻辑复用。</a:t>
             </a:r>
           </a:p>
         </p:txBody>
@@ -477,17 +481,26 @@
           <a:lstStyle/>
           <a:p>
             <a:r>
-              <a:t>脏页怎么来的：业务线程改页时调 MarkBufferDirty 置 BM_DIRTY，并把 buffer 挂进脏页队列。清理它们有两条后台路径。第一条是 bgwriter——BgBufferSync(bufmgr.cpp:4296) 跟着 freelist 的时钟指针顺扫，对可复用脏页调 SyncOneBuffer(第 4544 行) 预先写干净，让前台分配 buffer 时少等。第二条是增量检查点：ckpt_pagewriter_main(pagewriter.cpp:1763) 主循环 -&gt; ckpt_pagewriter_main_thread_flush_dirty_page(pagewriter.cpp:758) 排序脏页并唤醒子线程，子线程成批刷盘。</a:t>
-            </a:r>
-          </a:p>
-          <a:p>
-            <a:r>
-              <a:t>关键纠偏（文档 vs 开源）：宣传里的"去双写/double-write 消除"被夸大。开源 6.0.0 这里 dw_perform_batch_flush 仍是先 dw_copy_page 把整批脏页拷进 double-write 文件、dw_batch_flush 落盘，之后才逐页 FlushBuffer 写回数据文件——经典双写防"页撕裂"。是否启用由 dw_enabled() 即 GUC 控制；段页式表另有 seg_dw_single_flush。所谓"去双写"实为 ADIO 适配路径（GUC enable_adio_function 开启），是新增适配而非移除双写。不能把开源 openGauss 等同于 GaussDB 商业版。</a:t>
-            </a:r>
-          </a:p>
-          <a:p>
-            <a:r>
-              <a:t>观测视图（文档侧）：BGWRITER_STAT 看后台写吞吐、GLOBAL_CKPT_STATUS 看检查点进度、GLOBAL_DOUBLE_WRITE_STATUS 看双写文件使用情况。</a:t>
+              <a:rPr lang="zh-CN" dirty="0"/>
+              <a:t>脏页怎么来的:业务线程改页时 MarkBufferDirty 置 BM_DIRTY,并挂进脏页队列。清理有两条后台路径。</a:t>
+            </a:r>
+          </a:p>
+          <a:p>
+            <a:r>
+              <a:rPr lang="zh-CN" dirty="0"/>
+              <a:t>第一条 bgwriter:BgBufferSync 跟着 freelist 时钟指针顺扫,对可复用脏页提前 SyncOneBuffer 写干净,让前台分配 buffer 时少等。第二条增量检查点:pagewriter 主循环把脏页排序、唤醒子线程成批刷盘。</a:t>
+            </a:r>
+          </a:p>
+          <a:p>
+            <a:r>
+              <a:rPr lang="zh-CN" dirty="0"/>
+              <a:t>重点纠偏(文档 vs 开源):宣传的'去双写'被夸大。开源 6.0.0 这里仍是 dw_copy_page 把整批脏页拷进 double-write 文件、dw_batch_flush 落盘,之后才逐页 FlushBuffer 写回——经典双写防页撕裂,由 dw_enabled() 控制,段页式另有 seg_dw_single_flush。所谓'去双写'其实是 ADIO 适配路径(enable_adio_function),是新增适配不是移除。别把开源 openGauss 等同于 GaussDB 商业版。</a:t>
+            </a:r>
+          </a:p>
+          <a:p>
+            <a:r>
+              <a:rPr lang="zh-CN" dirty="0"/>
+              <a:t>观测视图:BGWRITER_STAT 看后台写吞吐,GLOBAL_CKPT_STATUS 看检查点进度,GLOBAL_DOUBLE_WRITE_STATUS 看双写文件使用。</a:t>
             </a:r>
           </a:p>
         </p:txBody>
@@ -557,22 +570,20 @@
           <a:lstStyle/>
           <a:p>
             <a:r>
-              <a:t>临时表（unlogged/temp）只在单个会话内可见，没必要进共享缓冲池。ReadBuffer_common 判断 relpersistence == RELPERSISTENCE_TEMP 时改走 LocalBufferAlloc，命中与淘汰都在会话私有结构里完成。</a:t>
-            </a:r>
-          </a:p>
-          <a:p>
-            <a:r>
-              <a:t>第 156 行先查会话私有哈希 LocalBufHash；命中就等价于 PinBuffer：bump usagecount、记 LocalRefCount，直接返回（第 190 行）。注意全程只用普通读写，没有 LockBufHdr/原子 CAS 那套共享池的并发保护——因为本地缓存天然无并发，省掉锁开销是它最大的特点。</a:t>
-            </a:r>
-          </a:p>
-          <a:p>
-            <a:r>
-              <a:t>未命中时进入第 203 行的本地时钟扫描（clock sweep）：从 nextFreeLocalBuf 起循环，usagecount&gt;0 就减一继续，归零的即可复用。若选中的旧 buffer 仍是 BM_DIRTY，会先 LocalBufferWrite 写回再复用（第 232-244 行）。</a:t>
-            </a:r>
-          </a:p>
-          <a:p>
-            <a:r>
-              <a:t>对应的置脏入口是 MarkLocalBufferDirty(localbuf.cpp:300)：第 318 行用 pg_atomic_fetch_or_u64 给 state 打上 BM_DIRTY，并按需累加本地脏页统计——同样没有共享池的那套锁路径。</a:t>
+              <a:rPr lang="zh-CN" dirty="0"/>
+              <a:t>临时表(temp/unlogged)只在单会话可见,没必要进共享缓冲池。ReadBuffer_common 判断 relpersistence 为 TEMP 时改走 LocalBufferAlloc,命中和淘汰都在会话私有结构里。</a:t>
+            </a:r>
+          </a:p>
+          <a:p>
+            <a:r>
+              <a:rPr lang="zh-CN" dirty="0"/>
+              <a:t>先查会话私有哈希 LocalBufHash;命中就等价于 PinBuffer:bump usagecount、记 LocalRefCount,直接返回。注意全程只用普通读写,没有 LockBufHdr/原子 CAS 那套共享池并发保护——本地缓存天然无并发,省掉锁开销正是它最大的特点。</a:t>
+            </a:r>
+          </a:p>
+          <a:p>
+            <a:r>
+              <a:rPr lang="zh-CN" dirty="0"/>
+              <a:t>未命中走本地 clock-sweep:从 nextFreeLocalBuf 起循环,usagecount&gt;0 减一继续,归零即可复用;选中的旧 buffer 若是脏页,先 LocalBufferWrite 写回再复用。对应置脏入口 MarkLocalBufferDirty 用原子 fetch_or 打 BM_DIRTY,同样不走共享池那套锁。</a:t>
             </a:r>
           </a:p>
         </p:txBody>
@@ -642,22 +653,26 @@
           <a:lstStyle/>
           <a:p>
             <a:r>
-              <a:t>这一页讲 openGauss 的系统目录(catalog)三级缓存。SearchSysCache(syscache.cpp:959) 是统一入口，按 cacheId 取到对应的 CatCache 后转调 SearchCatCache(catcache.cpp:1231)，再进 SearchCatCacheInternal 做真正工作。</a:t>
-            </a:r>
-          </a:p>
-          <a:p>
-            <a:r>
-              <a:t>快路径很短：先用 cc_hashfunc 算 hashValue，HASH_INDEX 定位到某个哈希桶 cc_bucket[hashIndex]，沿该桶的双向链表(Dllist)逐项比较 hash_value 与 fastequal 键。命中后用 DLMoveToFront 把该项挪到链头，形成 LRU，让热点元组后续查得更快；正项 refcount++ 返回元组指针，负项(negative)直接返回 NULL —— 负缓存避免对不存在的 key 反复扫表。</a:t>
-            </a:r>
-          </a:p>
-          <a:p>
-            <a:r>
-              <a:t>整桶扫完没命中，才调 SearchCatCacheMiss(catcache.cpp:1579) 这条慢路径：heap_open 打开真实系统表，systable_beginscan/getnext 走索引或堆扫描取一行，再 CatalogCacheCreateEntry 建缓存项(找不到则建负项)。把慢路径单独拆出来是为了让快路径尽量小、避免被内联拖累。</a:t>
-            </a:r>
-          </a:p>
-          <a:p>
-            <a:r>
-              <a:t>表级别则由 RelationIdGetRelation(relcache.cpp:3353) 负责：先 RelationIdCacheLookup 查 RelCache 哈希表，命中即增引用计数返回；未命中调 RelationBuildDesc(relcache.cpp:2243) 从 pg_class/pg_attribute 等目录重建整个 Relation 描述符。CatCache 缓存"行"，RelCache 缓存"表结构"，二者互相依赖、共同构成元数据访问的基础。</a:t>
+              <a:rPr lang="zh-CN" dirty="0"/>
+              <a:t>这页讲系统目录(catalog)的三级缓存。入口 SearchSysCache 按 cacheId 取到对应 CatCache,转 SearchCatCache 再进 SearchCatCacheInternal 干活。</a:t>
+            </a:r>
+          </a:p>
+          <a:p>
+            <a:r>
+              <a:rPr lang="zh-CN" dirty="0"/>
+              <a:t>快路径很短:cc_hashfunc 算 hashValue 定位哈希桶,沿桶内双向链表比键。命中后 DLMoveToFront 把它挪到链头形成 LRU,让热点行后续更快;正项 refcount++ 返回,负项直接返回 NULL——负缓存避免对不存在的 key 反复扫表。</a:t>
+            </a:r>
+          </a:p>
+          <a:p>
+            <a:r>
+              <a:rPr lang="zh-CN" dirty="0"/>
+              <a:t>整桶没命中才走慢路径 SearchCatCacheMiss:heap_open 打开真实系统表,扫一行,再建缓存项(找不到就建负项)。慢路径单独拆出,是为了让快路径足够小。</a:t>
+            </a:r>
+          </a:p>
+          <a:p>
+            <a:r>
+              <a:rPr lang="zh-CN" dirty="0"/>
+              <a:t>表级别由 RelationIdGetRelation 负责:先查 RelCache 哈希,命中即加引用返回;未命中 RelationBuildDesc 从 pg_class、pg_attribute 重建整个 Relation 描述符。一句话:CatCache 缓存'行',RelCache 缓存'表结构',二者互相依赖。</a:t>
             </a:r>
           </a:p>
         </p:txBody>
@@ -727,22 +742,26 @@
           <a:lstStyle/>
           <a:p>
             <a:r>
-              <a:t>这一页讲准备语句(prepared statement)/PBE 的执行计划缓存。一条语句的计划缓存对象 CachedPlanSource 经三步建立：CreateCachedPlan(plancache.cpp:192) 用 raw parse tree 建壳，CompleteCachedPlan(plancache.cpp:443) 填入 querytree、参数类型与游标选项完成定型，之后每次执行调 GetCachedPlan 取可用计划。</a:t>
-            </a:r>
-          </a:p>
-          <a:p>
-            <a:r>
-              <a:t>GetCachedPlan 先 RevalidateCachedQuery：若期间发生 DDL/失效，会重新分析重写并补齐 parse-time 锁，保证 querytree 仍然有效。然后 ChooseCustomPlan 基于通用计划估算成本与定制计划历史成本，决定本次用 generic plan 还是 custom plan —— 这是 openGauss 对带参语句"一次规划多次执行"与"按实参定制"之间的权衡。</a:t>
-            </a:r>
-          </a:p>
-          <a:p>
-            <a:r>
-              <a:t>走通用计划时，CheckCachedPlan 验证已缓存的 plansource-&gt;gplan 是否仍有效：有效就直接复用，并用 UniqueSQLStatCountSoftParse(1) 记一次软解析(soft parse)，省掉重新规划开销；无效则 ReleaseGenericPlan 丢弃旧计划，BuildCachedPlanInTransientContext 在临时上下文重建，挂回 gplan 并更新 generic_cost。</a:t>
-            </a:r>
-          </a:p>
-          <a:p>
-            <a:r>
-              <a:t>customplan 分支则用 boundParams 实参构建定制计划，挂到 plansource-&gt;cplan，并累计 total_custom_cost / num_custom_plans 供下次 ChooseCustomPlan 决策。最后统一把 plan-&gt;refcount++ 并按 useResOwner 登记到 ResourceOwner，确保引用计数与资源释放正确。</a:t>
+              <a:rPr lang="zh-CN" dirty="0"/>
+              <a:t>这页讲准备语句(PBE)的执行计划缓存。一条语句的 CachedPlanSource 分三步建立:CreateCachedPlan 建壳,CompleteCachedPlan 填 querytree、参数类型、游标选项定型,之后每次执行调 GetCachedPlan 取计划。</a:t>
+            </a:r>
+          </a:p>
+          <a:p>
+            <a:r>
+              <a:rPr lang="zh-CN" dirty="0"/>
+              <a:t>GetCachedPlan 先 RevalidateCachedQuery:若期间有 DDL 失效,重新分析重写、补齐锁。再 ChooseCustomPlan 比较通用计划估算成本和定制计划历史成本,决定这次用 generic 还是 custom——这是带参语句'一次规划多次执行'与'按实参定制'之间的权衡。</a:t>
+            </a:r>
+          </a:p>
+          <a:p>
+            <a:r>
+              <a:rPr lang="zh-CN" dirty="0"/>
+              <a:t>走通用计划:CheckCachedPlan 验证缓存的 gplan 是否仍有效,有效就复用并记一次软解析(soft parse),省掉重新规划;无效就丢弃旧计划、在临时上下文重建。</a:t>
+            </a:r>
+          </a:p>
+          <a:p>
+            <a:r>
+              <a:rPr lang="zh-CN" dirty="0"/>
+              <a:t>走定制计划:用实参 boundParams 构建计划挂到 cplan,并累计 custom 成本供下次决策。最后统一 refcount++ 并登记到 ResourceOwner,保证引用计数和释放正确。</a:t>
             </a:r>
           </a:p>
         </p:txBody>
@@ -812,496 +831,26 @@
           <a:lstStyle/>
           <a:p>
             <a:r>
-              <a:rPr dirty="0" err="1"/>
-              <a:t>这一页讲</a:t>
-            </a:r>
-            <a:r>
-              <a:rPr dirty="0"/>
-              <a:t> </a:t>
-            </a:r>
-            <a:r>
-              <a:rPr dirty="0" err="1"/>
-              <a:t>openGauss</a:t>
-            </a:r>
-            <a:r>
-              <a:rPr dirty="0"/>
-              <a:t> </a:t>
-            </a:r>
-            <a:r>
-              <a:rPr dirty="0" err="1"/>
-              <a:t>区别于原生</a:t>
-            </a:r>
-            <a:r>
-              <a:rPr dirty="0"/>
-              <a:t> PostgreSQL </a:t>
-            </a:r>
-            <a:r>
-              <a:rPr dirty="0" err="1"/>
-              <a:t>的两个跨会话共享缓存。原生</a:t>
-            </a:r>
-            <a:r>
-              <a:rPr dirty="0"/>
-              <a:t> PG 的 </a:t>
-            </a:r>
-            <a:r>
-              <a:rPr dirty="0" err="1"/>
-              <a:t>SysCache</a:t>
-            </a:r>
-            <a:r>
-              <a:rPr dirty="0"/>
-              <a:t>/</a:t>
-            </a:r>
-            <a:r>
-              <a:rPr dirty="0" err="1"/>
-              <a:t>RelCache</a:t>
-            </a:r>
-            <a:r>
-              <a:rPr dirty="0"/>
-              <a:t>/</a:t>
-            </a:r>
-            <a:r>
-              <a:rPr dirty="0" err="1"/>
-              <a:t>PlanCache</a:t>
-            </a:r>
-            <a:r>
-              <a:rPr dirty="0"/>
-              <a:t> </a:t>
-            </a:r>
-            <a:r>
-              <a:rPr dirty="0" err="1"/>
-              <a:t>都是每会话</a:t>
-            </a:r>
-            <a:r>
-              <a:rPr dirty="0"/>
-              <a:t>(</a:t>
-            </a:r>
-            <a:r>
-              <a:rPr dirty="0" err="1"/>
-              <a:t>进程</a:t>
-            </a:r>
-            <a:r>
-              <a:rPr dirty="0"/>
-              <a:t>)</a:t>
-            </a:r>
-            <a:r>
-              <a:rPr dirty="0" err="1"/>
-              <a:t>各一份，连接越多元数据副本越多、内存浪费越大。openGauss</a:t>
-            </a:r>
-            <a:r>
-              <a:rPr dirty="0"/>
-              <a:t> </a:t>
-            </a:r>
-            <a:r>
-              <a:rPr dirty="0" err="1"/>
-              <a:t>引入</a:t>
-            </a:r>
-            <a:r>
-              <a:rPr dirty="0"/>
-              <a:t> GSC(Global </a:t>
-            </a:r>
-            <a:r>
-              <a:rPr dirty="0" err="1"/>
-              <a:t>SysCache</a:t>
-            </a:r>
-            <a:r>
-              <a:rPr dirty="0"/>
-              <a:t>) 与 GPC(Global Plan Cache)，</a:t>
-            </a:r>
-            <a:r>
-              <a:rPr dirty="0" err="1"/>
-              <a:t>把只读、可共享的部分提升到实例</a:t>
-            </a:r>
-            <a:r>
-              <a:rPr dirty="0"/>
-              <a:t>(</a:t>
-            </a:r>
-            <a:r>
-              <a:rPr dirty="0" err="1"/>
-              <a:t>进程组</a:t>
-            </a:r>
-            <a:r>
-              <a:rPr dirty="0"/>
-              <a:t>)</a:t>
-            </a:r>
-            <a:r>
-              <a:rPr dirty="0" err="1"/>
-              <a:t>级别</a:t>
-            </a:r>
-            <a:r>
-              <a:rPr dirty="0"/>
-              <a:t>。</a:t>
-            </a:r>
-          </a:p>
-          <a:p>
-            <a:r>
-              <a:rPr dirty="0" err="1"/>
-              <a:t>SysCache</a:t>
-            </a:r>
-            <a:r>
-              <a:rPr dirty="0"/>
-              <a:t> </a:t>
-            </a:r>
-            <a:r>
-              <a:rPr dirty="0" err="1"/>
-              <a:t>侧分两层：每会话有</a:t>
-            </a:r>
-            <a:r>
-              <a:rPr dirty="0"/>
-              <a:t> </a:t>
-            </a:r>
-            <a:r>
-              <a:rPr dirty="0" err="1"/>
-              <a:t>LocalSysCache</a:t>
-            </a:r>
-            <a:r>
-              <a:rPr dirty="0"/>
-              <a:t>(</a:t>
-            </a:r>
-            <a:r>
-              <a:rPr dirty="0" err="1"/>
-              <a:t>LSC，含</a:t>
-            </a:r>
-            <a:r>
-              <a:rPr dirty="0"/>
-              <a:t> </a:t>
-            </a:r>
-            <a:r>
-              <a:rPr dirty="0" err="1"/>
-              <a:t>systabcache</a:t>
-            </a:r>
-            <a:r>
-              <a:rPr dirty="0"/>
-              <a:t>/</a:t>
-            </a:r>
-            <a:r>
-              <a:rPr dirty="0" err="1"/>
-              <a:t>tabdefcache，对应前面</a:t>
-            </a:r>
-            <a:r>
-              <a:rPr dirty="0"/>
-              <a:t> </a:t>
-            </a:r>
-            <a:r>
-              <a:rPr dirty="0" err="1"/>
-              <a:t>SearchSysCache、RelationIdGetRelation</a:t>
-            </a:r>
-            <a:r>
-              <a:rPr dirty="0"/>
-              <a:t> 里 </a:t>
-            </a:r>
-            <a:r>
-              <a:rPr dirty="0" err="1"/>
-              <a:t>EnableLocalSysCache</a:t>
-            </a:r>
-            <a:r>
-              <a:rPr dirty="0"/>
-              <a:t>() </a:t>
-            </a:r>
-            <a:r>
-              <a:rPr dirty="0" err="1"/>
-              <a:t>为真的分支</a:t>
-            </a:r>
-            <a:r>
-              <a:rPr dirty="0"/>
-              <a:t>)；</a:t>
-            </a:r>
-            <a:r>
-              <a:rPr dirty="0" err="1"/>
-              <a:t>其后是全局三级结构</a:t>
-            </a:r>
-            <a:r>
-              <a:rPr dirty="0"/>
-              <a:t> </a:t>
-            </a:r>
-            <a:r>
-              <a:rPr dirty="0" err="1"/>
-              <a:t>GlobalSysDBCache</a:t>
-            </a:r>
-            <a:r>
-              <a:rPr dirty="0"/>
-              <a:t>(knl_globalsysdbcache.h:61) -&gt; </a:t>
-            </a:r>
-            <a:r>
-              <a:rPr dirty="0" err="1"/>
-              <a:t>GlobalSysTabCache</a:t>
-            </a:r>
-            <a:r>
-              <a:rPr dirty="0"/>
-              <a:t>(knl_globalsystabcache.h:40) -&gt; </a:t>
-            </a:r>
-            <a:r>
-              <a:rPr dirty="0" err="1"/>
-              <a:t>GlobalSysTupCache</a:t>
-            </a:r>
-            <a:r>
-              <a:rPr dirty="0"/>
-              <a:t>(knl_globalsystupcache.h:241)，</a:t>
-            </a:r>
-            <a:r>
-              <a:rPr dirty="0" err="1"/>
-              <a:t>分别按数据库、按表、按元组组织共享内容。会话本地未命中时回源到全局层，命中即多会话共享同一份目录元组</a:t>
-            </a:r>
-            <a:r>
-              <a:rPr dirty="0"/>
-              <a:t>。</a:t>
-            </a:r>
-          </a:p>
-          <a:p>
-            <a:r>
-              <a:rPr dirty="0"/>
-              <a:t>Plan </a:t>
-            </a:r>
-            <a:r>
-              <a:rPr dirty="0" err="1"/>
-              <a:t>侧由</a:t>
-            </a:r>
-            <a:r>
-              <a:rPr dirty="0"/>
-              <a:t> </a:t>
-            </a:r>
-            <a:r>
-              <a:rPr dirty="0" err="1"/>
-              <a:t>GlobalPlanCache</a:t>
-            </a:r>
-            <a:r>
-              <a:rPr dirty="0"/>
-              <a:t>(globalplancache.h:41) </a:t>
-            </a:r>
-            <a:r>
-              <a:rPr dirty="0" err="1"/>
-              <a:t>管理：Fetch</a:t>
-            </a:r>
-            <a:r>
-              <a:rPr dirty="0"/>
-              <a:t> 按 query </a:t>
-            </a:r>
-            <a:r>
-              <a:rPr dirty="0" err="1"/>
-              <a:t>文本+参数在全局哈希表里找已编译的</a:t>
-            </a:r>
-            <a:r>
-              <a:rPr dirty="0"/>
-              <a:t> </a:t>
-            </a:r>
-            <a:r>
-              <a:rPr dirty="0" err="1"/>
-              <a:t>CachedPlanSource</a:t>
-            </a:r>
-            <a:r>
-              <a:rPr dirty="0"/>
-              <a:t> </a:t>
-            </a:r>
-            <a:r>
-              <a:rPr dirty="0" err="1"/>
-              <a:t>复用，TryStore</a:t>
-            </a:r>
-            <a:r>
-              <a:rPr dirty="0"/>
-              <a:t>(globalplancache.h:57) </a:t>
-            </a:r>
-            <a:r>
-              <a:rPr dirty="0" err="1"/>
-              <a:t>把本会话新建的可共享计划存入全局表，让其它会话省去重复硬解析</a:t>
-            </a:r>
-            <a:r>
-              <a:rPr dirty="0"/>
-              <a:t>。</a:t>
-            </a:r>
-          </a:p>
-          <a:p>
-            <a:r>
-              <a:rPr dirty="0" err="1"/>
-              <a:t>两者分别由</a:t>
-            </a:r>
-            <a:r>
-              <a:rPr dirty="0"/>
-              <a:t> GUC </a:t>
-            </a:r>
-            <a:r>
-              <a:rPr dirty="0" err="1"/>
-              <a:t>控制：enable_global_syscache</a:t>
-            </a:r>
-            <a:r>
-              <a:rPr dirty="0"/>
-              <a:t>(guc.cpp:1784) </a:t>
-            </a:r>
-            <a:r>
-              <a:rPr dirty="0" err="1"/>
-              <a:t>默认</a:t>
-            </a:r>
-            <a:r>
-              <a:rPr dirty="0"/>
-              <a:t> </a:t>
-            </a:r>
-            <a:r>
-              <a:rPr dirty="0" err="1"/>
-              <a:t>on，enable_global_plancache</a:t>
-            </a:r>
-            <a:r>
-              <a:rPr dirty="0"/>
-              <a:t>(guc.cpp:1743) </a:t>
-            </a:r>
-            <a:r>
-              <a:rPr dirty="0" err="1"/>
-              <a:t>默认</a:t>
-            </a:r>
-            <a:r>
-              <a:rPr dirty="0"/>
-              <a:t> off。</a:t>
-            </a:r>
-          </a:p>
-          <a:p>
-            <a:r>
-              <a:rPr dirty="0" err="1"/>
-              <a:t>文档</a:t>
-            </a:r>
-            <a:r>
-              <a:rPr dirty="0"/>
-              <a:t> vs </a:t>
-            </a:r>
-            <a:r>
-              <a:rPr dirty="0" err="1"/>
-              <a:t>开源差异</a:t>
-            </a:r>
-            <a:r>
-              <a:rPr dirty="0"/>
-              <a:t>(</a:t>
-            </a:r>
-            <a:r>
-              <a:rPr dirty="0" err="1"/>
-              <a:t>必须说明</a:t>
-            </a:r>
-            <a:r>
-              <a:rPr dirty="0"/>
-              <a:t>)：</a:t>
-            </a:r>
-            <a:r>
-              <a:rPr dirty="0" err="1"/>
-              <a:t>商业版</a:t>
-            </a:r>
-            <a:r>
-              <a:rPr dirty="0"/>
-              <a:t> </a:t>
-            </a:r>
-            <a:r>
-              <a:rPr dirty="0" err="1"/>
-              <a:t>GaussDB</a:t>
-            </a:r>
-            <a:r>
-              <a:rPr dirty="0"/>
-              <a:t> </a:t>
-            </a:r>
-            <a:r>
-              <a:rPr dirty="0" err="1"/>
-              <a:t>宣传的"Global</a:t>
-            </a:r>
-            <a:r>
-              <a:rPr dirty="0"/>
-              <a:t> PL/SQL </a:t>
-            </a:r>
-            <a:r>
-              <a:rPr dirty="0" err="1"/>
-              <a:t>Cache"覆盖面更广，但开源</a:t>
-            </a:r>
-            <a:r>
-              <a:rPr dirty="0"/>
-              <a:t> </a:t>
-            </a:r>
-            <a:r>
-              <a:rPr dirty="0" err="1"/>
-              <a:t>openGauss</a:t>
-            </a:r>
-            <a:r>
-              <a:rPr dirty="0"/>
-              <a:t> 6.0.0 </a:t>
-            </a:r>
-            <a:r>
-              <a:rPr dirty="0" err="1"/>
-              <a:t>中能找到的全局缓存仅限此处的</a:t>
-            </a:r>
-            <a:r>
-              <a:rPr dirty="0"/>
-              <a:t> GSC/GPC，PL/SQL </a:t>
-            </a:r>
-            <a:r>
-              <a:rPr dirty="0" err="1"/>
-              <a:t>侧只有</a:t>
-            </a:r>
-            <a:r>
-              <a:rPr dirty="0"/>
-              <a:t> </a:t>
-            </a:r>
-            <a:r>
-              <a:rPr dirty="0" err="1"/>
-              <a:t>src</a:t>
-            </a:r>
-            <a:r>
-              <a:rPr dirty="0"/>
-              <a:t>/common/pl/</a:t>
-            </a:r>
-            <a:r>
-              <a:rPr dirty="0" err="1"/>
-              <a:t>plpgsql</a:t>
-            </a:r>
-            <a:r>
-              <a:rPr dirty="0"/>
-              <a:t>/</a:t>
-            </a:r>
-            <a:r>
-              <a:rPr dirty="0" err="1"/>
-              <a:t>src</a:t>
-            </a:r>
-            <a:r>
-              <a:rPr dirty="0"/>
-              <a:t>/pl_global_package_runtime_cache.cpp </a:t>
-            </a:r>
-            <a:r>
-              <a:rPr dirty="0" err="1"/>
-              <a:t>这一处</a:t>
-            </a:r>
-            <a:r>
-              <a:rPr dirty="0"/>
-              <a:t> package </a:t>
-            </a:r>
-            <a:r>
-              <a:rPr dirty="0" err="1"/>
-              <a:t>运行时缓存，并不等于文档描述的完整</a:t>
-            </a:r>
-            <a:r>
-              <a:rPr dirty="0"/>
-              <a:t> Global PL/SQL Cache </a:t>
-            </a:r>
-            <a:r>
-              <a:rPr dirty="0" err="1"/>
-              <a:t>能力。讲解时不应把开源</a:t>
-            </a:r>
-            <a:r>
-              <a:rPr dirty="0"/>
-              <a:t> GSC/GPC </a:t>
-            </a:r>
-            <a:r>
-              <a:rPr dirty="0" err="1"/>
-              <a:t>直接等同于</a:t>
-            </a:r>
-            <a:r>
-              <a:rPr dirty="0"/>
-              <a:t> </a:t>
-            </a:r>
-            <a:r>
-              <a:rPr dirty="0" err="1"/>
-              <a:t>GaussDB</a:t>
-            </a:r>
-            <a:r>
-              <a:rPr dirty="0"/>
-              <a:t> </a:t>
-            </a:r>
-            <a:r>
-              <a:rPr dirty="0" err="1"/>
-              <a:t>商业版全部能力</a:t>
-            </a:r>
-            <a:r>
-              <a:rPr dirty="0"/>
-              <a:t>。</a:t>
+              <a:rPr lang="zh-CN" dirty="0"/>
+              <a:t>这页讲 openGauss 区别于原生 PG 的两个跨会话共享缓存。原生 PG 的 SysCache、RelCache、PlanCache 每会话各一份,连接越多副本越多、越费内存。openGauss 用 GSC(Global SysCache)和 GPC(Global Plan Cache),把只读可共享的部分提升到实例级。</a:t>
+            </a:r>
+          </a:p>
+          <a:p>
+            <a:r>
+              <a:rPr lang="zh-CN" dirty="0"/>
+              <a:t>SysCache 分两层:每会话有 LocalSysCache(LSC),其后是全局三级 GlobalSysDBCache → GlobalSysTabCache → GlobalSysTupCache,分别按库、按表、按元组组织。会话本地未命中就回源到全局层,命中即多会话共享同一份目录元组。</a:t>
+            </a:r>
+          </a:p>
+          <a:p>
+            <a:r>
+              <a:rPr lang="zh-CN" dirty="0"/>
+              <a:t>Plan 侧由 GlobalPlanCache 管:Fetch 按 query 文本加参数在全局哈希里找已编译的 CachedPlanSource 复用,TryStore 把本会话新建的可共享计划存进去,省掉别人重复硬解析。两者由 GUC 控制:enable_global_syscache 默认 on,enable_global_plancache 默认 off。</a:t>
+            </a:r>
+          </a:p>
+          <a:p>
+            <a:r>
+              <a:rPr lang="zh-CN" dirty="0"/>
+              <a:t>文档 vs 开源(要说明):商业版宣传的'Global PL/SQL Cache'覆盖更广,但开源 6.0.0 能找到的全局缓存只有这里的 GSC/GPC,PL/SQL 侧仅 pl_global_package_runtime_cache 一处 package 运行时缓存,并不等于完整的 Global PL/SQL Cache。别把开源 GSC/GPC 直接等同于商业版全部能力。</a:t>
             </a:r>
           </a:p>
         </p:txBody>
@@ -1371,7 +920,20 @@
           <a:lstStyle/>
           <a:p>
             <a:r>
-              <a:t>这页讲 SMGR 层的核心抽象。f_smgr 是一张函数指针表（vtable），每个介质实现填一行；smgrsw[] 把它们静态登记成数组。上层（如 BufferAlloc/FlushBuffer）只调 smgrread/smgrwrite，内部用 reln-&gt;smgr_which 作下标取出对应实现，例如 (*(smgrsw[reln-&gt;smgr_which].smgr_read))(...)，这就是运行时多态。注意源码真实下标：0=MD 经典单文件，1=undo file，2=segment-page 段页式，3=extreme-rto standby read——任务描述把段页式写成 index1 是简化，按源码应是 index2（宏 SEGMENT_MANAGER=2）。SMgrRelationData(smgr.h:48) 是每个物理关系的句柄，smgr_rnode 作哈希键，md_fd 给 MD 用、seg_desc/seg_space 给段页式用，smgr_which 决定走哪一行。smgropen 第一次访问时建哈希表并 HASH_ENTER 插入条目，并不真正打开文件，延迟到读写时再 _mdfd_getseg。</a:t>
+              <a:rPr lang="zh-CN" dirty="0"/>
+              <a:t>这页讲 SMGR 层的核心抽象。f_smgr 是一张函数指针表(vtable),每个介质实现填一行;smgrsw[] 把它们静态登记成数组。上层只调 smgrread/smgrwrite,内部用 reln-&gt;smgr_which 作下标取出实现,这就是运行时多态。</a:t>
+            </a:r>
+          </a:p>
+          <a:p>
+            <a:r>
+              <a:rPr lang="zh-CN" dirty="0"/>
+              <a:t>真实下标:0=MD 经典单文件,1=undo file,2=段页式,3=extreme-rto standby read。任务描述把段页式写成 index1 是简化,按源码应是 index2(宏 SEGMENT_MANAGER=2)。</a:t>
+            </a:r>
+          </a:p>
+          <a:p>
+            <a:r>
+              <a:rPr lang="zh-CN" dirty="0"/>
+              <a:t>SMgrRelationData 是每个物理关系的句柄:smgr_rnode 作哈希键,md_fd 给 MD 用,seg_desc/seg_space 给段页式用,smgr_which 决定走哪一行。smgropen 第一次访问时建哈希表、HASH_ENTER 插条目,并不真打开文件,延迟到读写时再 _mdfd_getseg。</a:t>
             </a:r>
           </a:p>
         </p:txBody>
@@ -1441,7 +1003,20 @@
           <a:lstStyle/>
           <a:p>
             <a:r>
-              <a:t>这页讲最经典的介质层。MD 把一个 relation fork 拆成多个固定大小段文件（RELSEG_SIZE，默认 1GB / BLCKSZ 块），用 _MdfdVec(smgr.h:108) 单链表串起来：mdfd_vfd 是 fd.c 虚拟文件描述符，mdfd_segno 段号，mdfd_chain 指向下一段。mdwrite 的关键两步：先 _mdfd_getseg 用 blocknum 算出该块落在哪一段并返回对应 _MdfdVec（EXTENSION_FAIL 表示越界即报错、写不扩段）；再算段内偏移 seekpos = BLCKSZ * (blocknum % RELSEG_SIZE)，最后 FilePWrite 定位写入。压缩主 fork 走 CfsWritePage 分支（此处省略）。mdwrite 只更新 EOF 之前已存在的块，扩展要用 mdextend；它不保证立即落盘，由后续 checkpoint/fsync 保证持久性。Assert 保证偏移不越段边界。</a:t>
+              <a:rPr lang="zh-CN" dirty="0"/>
+              <a:t>这页讲最经典的介质层 MD。它把一个 relation fork 拆成多个定长段文件(RELSEG_SIZE,默认 1GB),用 _MdfdVec 单链表串起来:mdfd_vfd 是虚拟文件描述符,mdfd_segno 段号,mdfd_chain 指向下一段。</a:t>
+            </a:r>
+          </a:p>
+          <a:p>
+            <a:r>
+              <a:rPr lang="zh-CN" dirty="0"/>
+              <a:t>mdwrite 两步:先 _mdfd_getseg 用 blocknum 算出该块在哪一段(EXTENSION_FAIL 表示越界报错、写不扩段);再算段内偏移 seekpos = BLCKSZ × (blocknum % RELSEG_SIZE),最后 FilePWrite 定位写入。压缩主 fork 走 CfsWritePage 分支。</a:t>
+            </a:r>
+          </a:p>
+          <a:p>
+            <a:r>
+              <a:rPr lang="zh-CN" dirty="0"/>
+              <a:t>注意:mdwrite 只更新 EOF 之前已存在的块,扩展要用 mdextend;它不保证立即落盘,持久性交给后续 checkpoint/fsync。Assert 保证偏移不越段边界。</a:t>
             </a:r>
           </a:p>
         </p:txBody>
@@ -1511,7 +1086,20 @@
           <a:lstStyle/>
           <a:p>
             <a:r>
-              <a:t>这页讲段页式读路径。和 MD「每关系独占文件」不同，段页式把同表空间多关系塞进表空间级物理大文件（按 1/8/128/...块的 extent 分级），逻辑块号必须先映射成物理块号。seg_read 流程：read_head_buffer 把该 fork 的 SegmentHead 读进共享缓冲（seg_desc[forknum]-&gt;head_blocknum 记录段头位置）；校验 blocknum &lt; seg_head-&gt;nblocks；seg_logic_to_physic_mapping 通过段头里的多级 BMT 把逻辑块号翻译成物理 loc(extent_size, blocknum)；再 spc_read_block 按 EXTENT_TYPE_TO_GROUPID 选中 SegSpace-&gt;extent_group[egid][forknum]，调 df_pread_block 从对应 SegLogicFile 读出。读完 PageIsVerified 校验 CRC，决定返回 OK 还是 CRC_ERROR；写路径 seg_write(:1580) 对称，末尾 spc_write_block。文档侧可用 GS_SEG_* 系统视图（如 gs_seg_spc/segment 一类）观察段页式表空间占用。差异提醒（文档 vs 开源）：商业版宣传的「去双写」在开源 6.0.0 并不成立——段页式刷脏仍会调用 seg_dw_single_flush（受 dw_enabled() 控制），ADIO 仅由 GUC enable_adio_function 适配而非移除双写；不要把开源 openGauss 段页式等同于 GaussDB 商业版能力。</a:t>
+              <a:rPr lang="zh-CN" dirty="0"/>
+              <a:t>这页讲段页式读路径。和 MD'每关系独占文件'不同,段页式把同表空间的多关系塞进表空间级物理大文件(按 1/8/128… 块分级 extent),逻辑块号得先映射成物理块号。</a:t>
+            </a:r>
+          </a:p>
+          <a:p>
+            <a:r>
+              <a:rPr lang="zh-CN" dirty="0"/>
+              <a:t>seg_read 流程:read_head_buffer 把该 fork 的 SegmentHead 读进缓冲;校验 blocknum 小于 nblocks;seg_logic_to_physic_mapping 通过段头里的多级 BMT 把逻辑块翻译成物理 loc;再 spc_read_block 按 extent 选中对应 extent_group,调 df_pread_block 从 SegLogicFile 读出。读完 PageIsVerified 校验 CRC。写路径 seg_write 对称,末尾 spc_write_block。</a:t>
+            </a:r>
+          </a:p>
+          <a:p>
+            <a:r>
+              <a:rPr lang="zh-CN" dirty="0"/>
+              <a:t>观测:文档侧可用 GS_SEG_* 系统视图看段页式表空间占用。差异提醒:商业版宣传的'去双写'在开源 6.0.0 不成立——段页式刷脏仍调 seg_dw_single_flush(受 dw_enabled() 控制),ADIO 只是 enable_adio_function 适配,不是移除双写。</a:t>
             </a:r>
           </a:p>
         </p:txBody>
@@ -1581,22 +1169,26 @@
           <a:lstStyle/>
           <a:p>
             <a:r>
-              <a:t>这一页讲页面的物理布局和两个基础操作。PageInit 把整页清零, 然后把页面切成上下两段空闲指针: pd_lower 指向页头之后线指针数组的末端(空闲空间起点), pd_upper 指向元组区的顶端(空闲空间终点), pd_special 指向页尾 special 区起点。</a:t>
-            </a:r>
-          </a:p>
-          <a:p>
-            <a:r>
-              <a:t>注意 isHeap 分支: 堆页用 SizeOfHeapPageHeaderData, 因为 HeapPageHeaderData 比通用 PageHeaderData 多了 pd_xid_base 和 pd_multi_base 两个 64 位字段(bufpage.h:162), 这是 openGauss 用页内 base + 32 位短 XID 拼出 64 位事务号的关键, 解决了 PostgreSQL 32 位 XID 回卷问题。</a:t>
-            </a:r>
-          </a:p>
-          <a:p>
-            <a:r>
-              <a:t>插入数据时, PageAddItem(redo_bufpage.cpp:720) 先校验 pd_lower/pd_upper/pd_special 没被写坏, 再挑一个 offset, 把元组拷到 pd_upper 之下、把 ItemId 写进 pd_linp 数组, 即线指针自顶向下增长、元组自底向上增长, 两头相遇即页满。每个 ItemId 是 ItemIdData(itemid.h:24), 用位域把偏移、状态、长度压进 4 字节: lp_off 和 lp_len 各 15 位, 所以页面最大只能到 32KB。</a:t>
-            </a:r>
-          </a:p>
-          <a:p>
-            <a:r>
-              <a:t>关于 TOAST: 当字段超长放不进一页时, 标准做法是切片存到 TOAST 副表并在主元组留指针, 这是社区 PostgreSQL 既有能力。文档里的 Enhanced Toast 是 GaussDB 商业版宣传特性, 在开源 openGauss 6.0.0 源码中未找到实现, 讲解时不能把开源等同于商业版。</a:t>
+              <a:rPr lang="zh-CN" dirty="0"/>
+              <a:t>这页讲页面的物理布局和两个基础操作。PageInit 把整页清零,再用空闲指针切成几段:pd_lower 指到线指针数组末端(空闲起点),pd_upper 指到元组区顶端(空闲终点),pd_special 指到页尾 special 区。</a:t>
+            </a:r>
+          </a:p>
+          <a:p>
+            <a:r>
+              <a:rPr lang="zh-CN" dirty="0"/>
+              <a:t>注意 isHeap 分支:堆页用 SizeOfHeapPageHeaderData,因为堆页头比通用页头多了 pd_xid_base、pd_multi_base 两个 64 位字段——这是 openGauss 用'页内 base + 32 位短 XID'拼出 64 位事务号的关键,解决了 PG 的 32 位 XID 回卷问题。</a:t>
+            </a:r>
+          </a:p>
+          <a:p>
+            <a:r>
+              <a:rPr lang="zh-CN" dirty="0"/>
+              <a:t>插入时 PageAddItem 先校验三个指针没被写坏,再挑 offset,把元组拷到 pd_upper 之下、把 ItemId 写进 pd_linp 数组:线指针自顶向下增长、元组自底向上增长,两头相遇即页满。每个 ItemId 用位域把偏移、状态、长度压进 4 字节,lp_off、lp_len 各 15 位,所以页面最大到 32KB。</a:t>
+            </a:r>
+          </a:p>
+          <a:p>
+            <a:r>
+              <a:rPr lang="zh-CN" dirty="0"/>
+              <a:t>关于 TOAST:字段超长放不进一页时,标准做法是切片存到 TOAST 副表、主元组留指针,这是社区 PG 既有能力。文档里的 Enhanced Toast 是 GaussDB 商业版特性,开源 6.0.0 源码里没找到实现,讲解时别把开源等同于商业版。</a:t>
             </a:r>
           </a:p>
         </p:txBody>
@@ -1666,170 +1258,26 @@
           <a:lstStyle/>
           <a:p>
             <a:r>
-              <a:rPr dirty="0" err="1"/>
-              <a:t>本讲分四部分。总览先校准</a:t>
-            </a:r>
-            <a:r>
-              <a:rPr dirty="0"/>
-              <a:t> </a:t>
-            </a:r>
-            <a:r>
-              <a:rPr dirty="0" err="1"/>
-              <a:t>openGauss</a:t>
-            </a:r>
-            <a:r>
-              <a:rPr dirty="0"/>
-              <a:t> 与 </a:t>
-            </a:r>
-            <a:r>
-              <a:rPr dirty="0" err="1"/>
-              <a:t>GaussDB</a:t>
-            </a:r>
-            <a:r>
-              <a:rPr dirty="0"/>
-              <a:t> </a:t>
-            </a:r>
-            <a:r>
-              <a:rPr dirty="0" err="1"/>
-              <a:t>的边界并给出存储全景与读路径地图</a:t>
-            </a:r>
-            <a:r>
-              <a:rPr dirty="0"/>
-              <a:t>;</a:t>
-            </a:r>
-          </a:p>
-          <a:p>
-            <a:r>
-              <a:rPr dirty="0" err="1"/>
-              <a:t>缓存管理深入共享缓冲池的查找</a:t>
-            </a:r>
-            <a:r>
-              <a:rPr dirty="0"/>
-              <a:t>/</a:t>
-            </a:r>
-            <a:r>
-              <a:rPr dirty="0" err="1"/>
-              <a:t>淘汰</a:t>
-            </a:r>
-            <a:r>
-              <a:rPr dirty="0"/>
-              <a:t>/</a:t>
-            </a:r>
-            <a:r>
-              <a:rPr dirty="0" err="1"/>
-              <a:t>刷盘以及系统缓存与计划缓存</a:t>
-            </a:r>
-            <a:r>
-              <a:rPr dirty="0"/>
-              <a:t>(含 </a:t>
-            </a:r>
-            <a:r>
-              <a:rPr dirty="0" err="1"/>
-              <a:t>openGauss</a:t>
-            </a:r>
-            <a:r>
-              <a:rPr dirty="0"/>
-              <a:t> </a:t>
-            </a:r>
-            <a:r>
-              <a:rPr dirty="0" err="1"/>
-              <a:t>特有的</a:t>
-            </a:r>
-            <a:r>
-              <a:rPr dirty="0"/>
-              <a:t> GSC/GPC);</a:t>
-            </a:r>
-          </a:p>
-          <a:p>
-            <a:r>
-              <a:rPr dirty="0" err="1"/>
-              <a:t>持久化存储管理自</a:t>
-            </a:r>
-            <a:r>
-              <a:rPr dirty="0"/>
-              <a:t> SMGR </a:t>
-            </a:r>
-            <a:r>
-              <a:rPr dirty="0" err="1"/>
-              <a:t>抽象向下讲</a:t>
-            </a:r>
-            <a:r>
-              <a:rPr dirty="0"/>
-              <a:t> </a:t>
-            </a:r>
-            <a:r>
-              <a:rPr dirty="0" err="1"/>
-              <a:t>MD、段页式、页面布局、FSM、WAL</a:t>
-            </a:r>
-            <a:r>
-              <a:rPr dirty="0"/>
-              <a:t> </a:t>
-            </a:r>
-            <a:r>
-              <a:rPr dirty="0" err="1"/>
-              <a:t>与检查点</a:t>
-            </a:r>
-            <a:r>
-              <a:rPr dirty="0"/>
-              <a:t>, </a:t>
-            </a:r>
-            <a:r>
-              <a:rPr dirty="0" err="1"/>
-              <a:t>以及</a:t>
-            </a:r>
-            <a:r>
-              <a:rPr dirty="0"/>
-              <a:t> Astore/</a:t>
-            </a:r>
-            <a:r>
-              <a:rPr dirty="0" err="1"/>
-              <a:t>Ustore</a:t>
-            </a:r>
-            <a:r>
-              <a:rPr dirty="0"/>
-              <a:t>/Undo </a:t>
-            </a:r>
-            <a:r>
-              <a:rPr dirty="0" err="1"/>
-              <a:t>三套引擎</a:t>
-            </a:r>
-            <a:r>
-              <a:rPr dirty="0"/>
-              <a:t>;</a:t>
-            </a:r>
-          </a:p>
-          <a:p>
-            <a:r>
-              <a:rPr dirty="0" err="1"/>
-              <a:t>端到端与保真度把两大主题缝合为一次</a:t>
-            </a:r>
-            <a:r>
-              <a:rPr dirty="0"/>
-              <a:t> UPDATE </a:t>
-            </a:r>
-            <a:r>
-              <a:rPr dirty="0" err="1"/>
-              <a:t>的完整链路</a:t>
-            </a:r>
-            <a:r>
-              <a:rPr dirty="0"/>
-              <a:t>, </a:t>
-            </a:r>
-            <a:r>
-              <a:rPr dirty="0" err="1"/>
-              <a:t>并以"文档</a:t>
-            </a:r>
-            <a:r>
-              <a:rPr dirty="0"/>
-              <a:t> vs </a:t>
-            </a:r>
-            <a:r>
-              <a:rPr dirty="0" err="1"/>
-              <a:t>开源"对照表收尾</a:t>
-            </a:r>
-            <a:r>
-              <a:rPr dirty="0"/>
-              <a:t>。</a:t>
+              <a:rPr lang="zh-CN" dirty="0"/>
+              <a:t>本讲分四部分。第一部分总览,先校准 openGauss 与 GaussDB 的边界,给出存储全景和读路径地图。</a:t>
+            </a:r>
+          </a:p>
+          <a:p>
+            <a:r>
+              <a:rPr lang="zh-CN" dirty="0"/>
+              <a:t>第二部分缓存管理,讲共享缓冲池的查找、淘汰、刷盘,以及系统缓存与计划缓存——含 openGauss 特有的 GSC 和 GPC。</a:t>
+            </a:r>
+          </a:p>
+          <a:p>
+            <a:r>
+              <a:rPr lang="zh-CN" dirty="0"/>
+              <a:t>第三部分持久化存储,从 SMGR 抽象往下:MD、段页式、页面布局、FSM、WAL 与检查点,以及 Astore、Ustore、Undo 三套引擎。</a:t>
+            </a:r>
+          </a:p>
+          <a:p>
+            <a:r>
+              <a:rPr lang="zh-CN" dirty="0"/>
+              <a:t>第四部分端到端与保真度,把两大主题缝成一次 UPDATE 的完整链路,最后用'文档 vs 开源'对照表收尾。</a:t>
             </a:r>
           </a:p>
         </p:txBody>
@@ -1899,22 +1347,26 @@
           <a:lstStyle/>
           <a:p>
             <a:r>
-              <a:t>这一页讲插入数据时如何快速找到一个有足够空间的页, 避免全表扫。每张表有一个伴随的 FSM(Free Space Map), 它把每个堆块的可用空间量化成一个字节的 category 档位。</a:t>
-            </a:r>
-          </a:p>
-          <a:p>
-            <a:r>
-              <a:t>查询路径: heap_insert 需要 spaceNeeded 字节, 调 GetPageWithFreeSpace。它先用 fsm_space_needed_to_cat 把字节数折成最低档位 min_cat, 再调 fsm_search 在 FSM 树里自顶向下走: 每个上层节点存的是其子树里的最大档位, 所以只要根节点的最大值 &gt;= min_cat 就一定能在下层找到候选块, 否则直接返回 InvalidBlockNumber 让上层去扩展关系。</a:t>
-            </a:r>
-          </a:p>
-          <a:p>
-            <a:r>
-              <a:t>更新路径是反向的: 插入后某页剩余空间变了, RecordPageWithFreeSpace(125) 用 fsm_space_avail_to_cat 把剩余字节折成 new_cat, 通过 fsm_get_location 定位到该堆块对应的 FSM 字节(addr+slot), 写回底层。注意它把上层 minValue 传 0, 即只改底层不强制刷上层; 上层聚合值可能暂时偏旧, 新增空间要等 FreeSpaceMapVacuum(366) 自顶向下扫一遍(fsm_vacuum_page 从 g_fsm_root_address 开始)才对查找完全可见, 这是性能与一致性的折中。</a:t>
-            </a:r>
-          </a:p>
-          <a:p>
-            <a:r>
-              <a:t>FSM 树是几层取决于 SlotsPerFSMPage: 8KB 块下每页约 4000 个槽, 满足三层树(FSM_TREE_DEPTH, freespace.h:65)。树的每个逻辑节点由 FSMAddress 寻址, 它只有两个字段 level(第几层)和 logpageno(该层内的页号), 把多层 FSM 抽象成可独立寻址的逻辑文件。</a:t>
+              <a:rPr lang="zh-CN" dirty="0"/>
+              <a:t>这页讲插入时怎么快速找到有足够空间的页,避免全表扫。每张表都有伴随的 FSM(Free Space Map),把每个堆块的可用空间量化成一字节的 category 档位。</a:t>
+            </a:r>
+          </a:p>
+          <a:p>
+            <a:r>
+              <a:rPr lang="zh-CN" dirty="0"/>
+              <a:t>查询路径:heap_insert 需要 spaceNeeded 字节,调 GetPageWithFreeSpace。先用 fsm_space_needed_to_cat 把字节折成最低档 min_cat,再 fsm_search 在 FSM 树里自顶向下走——上层节点存子树里的最大档位,所以只要根的最大值≥min_cat,下层一定找得到候选块;否则返回 InvalidBlockNumber,让上层去扩展关系。</a:t>
+            </a:r>
+          </a:p>
+          <a:p>
+            <a:r>
+              <a:rPr lang="zh-CN" dirty="0"/>
+              <a:t>更新路径反向:某页空间变了,RecordPageWithFreeSpace 用 fsm_space_avail_to_cat 折成 new_cat,经 fsm_get_location 定位到该块的 FSM 字节写回。注意它只改底层、不强刷上层(minValue 传 0),上层聚合值可能暂时偏旧,新空间要等 FreeSpaceMapVacuum 自顶向下扫一遍才完全可见——性能与一致性的折中。</a:t>
+            </a:r>
+          </a:p>
+          <a:p>
+            <a:r>
+              <a:rPr lang="zh-CN" dirty="0"/>
+              <a:t>结构:FSM 几层取决于 SlotsPerFSMPage,8KB 块下每页约 4000 槽,够撑三层树(FSM_TREE_DEPTH)。每个逻辑节点用 FSMAddress 寻址,只有 level 和 logpageno 两个字段,把多层 FSM 抽象成可独立寻址的逻辑文件。</a:t>
             </a:r>
           </a:p>
         </p:txBody>
@@ -1984,17 +1436,20 @@
           <a:lstStyle/>
           <a:p>
             <a:r>
-              <a:t>XLogInsertRecord 是把一条已组装好的 rdata 记录链写入 WAL 的统一入口。它本身不搬数据，只做"按平台与 GUC 选择插入策略"：在 aarch64 上，如果是日志切换记录(XLOG_SWITCH) 或没开 enable_xlog_insert_record_group，就走 single 模式逐条插入；否则走 group 模式，把多个后端的插入聚合，减少 insertpos_lck 自旋锁争用。x86 始终走 single。</a:t>
-            </a:r>
-          </a:p>
-          <a:p>
-            <a:r>
-              <a:t>真正分配空间与 LSN 的是下游 ReserveXLogInsertLocation：它在锁内只做一句 CurrBytePos += size，把"可用字节位置"映射成物理 XLogRecPtr(即 LSN)，得到 StartPos/EndPos/PrevPtr，随后把记录拷贝进 WAL 缓冲页。这样持锁时间最短，是高并发写入的关键。</a:t>
-            </a:r>
-          </a:p>
-          <a:p>
-            <a:r>
-              <a:t>结构 XLogRecord(xlog_basic.h:222) 是每条 WAL 记录的定长头：xl_tot_len 整条长度、xl_xid 事务号、xl_prev 指向上一条记录形成日志链、xl_info 标志位、xl_rmid 资源管理器(决定回放用哪套 redo)、xl_crc 校验码。WAL 物理上按段文件存放于 pg_xlog 目录，单段默认 16MB，写满即切换。</a:t>
+              <a:rPr lang="zh-CN" dirty="0"/>
+              <a:t>XLogInsertRecord 是把已组装好的 rdata 记录链写进 WAL 的统一入口。它自己不搬数据,只按平台和 GUC 选插入策略:aarch64 上,若是日志切换记录(XLOG_SWITCH)或没开 enable_xlog_insert_record_group,走 single 逐条插;否则走 group 模式,把多个后端的插入聚合,减少 insertpos_lck 自旋争用。x86 始终 single。</a:t>
+            </a:r>
+          </a:p>
+          <a:p>
+            <a:r>
+              <a:rPr lang="zh-CN" dirty="0"/>
+              <a:t>真正分配空间和 LSN 的是下游 ReserveXLogInsertLocation:它在锁内只做一句 CurrBytePos += size,把可用字节位置映射成物理 XLogRecPtr(即 LSN),拿到 StartPos/EndPos/PrevPtr,再把记录拷进 WAL 缓冲页。持锁时间最短,是高并发写入的关键。</a:t>
+            </a:r>
+          </a:p>
+          <a:p>
+            <a:r>
+              <a:rPr lang="zh-CN" dirty="0"/>
+              <a:t>结构 XLogRecord 是每条 WAL 记录的定长头:xl_tot_len 整条长度、xl_xid 事务号、xl_prev 指向上一条形成日志链、xl_info 标志、xl_rmid 资源管理器(决定回放用哪套 redo)、xl_crc 校验。WAL 物理上按段文件存于 pg_xlog,单段默认 16MB,写满即切换。</a:t>
             </a:r>
           </a:p>
         </p:txBody>
@@ -2064,17 +1519,20 @@
           <a:lstStyle/>
           <a:p>
             <a:r>
-              <a:t>XLogFlushCore 是把 WAL 真正落盘的核心。它进入临界区后构造一个 WriteRqst，把 Write 和 Flush 目标都设为 writeRqstPtr，调用 XLogWrite(2640) 完成写文件并 fsync；XLogWrite 必须在持有 WALWriteLock 时调用(见函数头注释 Must be called with WALWriteLock held)。落盘后用 pg_memory_barrier 保证可见性，唤醒 walsender 把日志发往备机，并用原子写更新 flushResult、唤醒等待提交的代理线程，让它们检查最新已刷 LSN。</a:t>
-            </a:r>
-          </a:p>
-          <a:p>
-            <a:r>
-              <a:t>无锁刷盘 self-flush 是 openGauss 的并发优化：XLogSelfFlushWithoutStatus(341 声明，3844 实现) 让插入线程在没有专职 walwriter、或一次拷贝内第二次命中起始页时，自己驱动刷盘并自旋等待 lastLRCFlushed 追平 prevLRC，避免全局写锁成为瓶颈。</a:t>
-            </a:r>
-          </a:p>
-          <a:p>
-            <a:r>
-              <a:t>LRC(Log Record Counter) 是这套机制的串行号：定义在 Combined128(xlog_internal.h:239) 里，和 64 位 CurrBytePos 打包成 128 位，用 atomic_compare_and_swap_u128 一次性原子推进(见 ReserveXLogInsertLocation)。刷盘侧据 LRC 判断记录拷贝是否完成、顺序是否连续，从而在多线程下安全推进 flush 水位。</a:t>
+              <a:rPr lang="zh-CN" dirty="0"/>
+              <a:t>XLogFlushCore 是把 WAL 真正落盘的核心。进临界区后构造 WriteRqst,把 Write 和 Flush 目标都设为 writeRqstPtr,调 XLogWrite 写文件并 fsync——XLogWrite 必须持 WALWriteLock 调用。落盘后用 pg_memory_barrier 保证可见性,唤醒 walsender 把日志发往备机,再原子更新 flushResult、唤醒等待提交的代理线程去检查最新已刷 LSN。</a:t>
+            </a:r>
+          </a:p>
+          <a:p>
+            <a:r>
+              <a:rPr lang="zh-CN" dirty="0"/>
+              <a:t>无锁刷盘 self-flush 是 openGauss 的并发优化:XLogSelfFlushWithoutStatus 让插入线程在没有专职 walwriter、或一次拷贝内第二次命中起始页时,自己驱动刷盘并自旋等 lastLRCFlushed 追平 prevLRC,避免全局写锁成为瓶颈。</a:t>
+            </a:r>
+          </a:p>
+          <a:p>
+            <a:r>
+              <a:rPr lang="zh-CN" dirty="0"/>
+              <a:t>LRC(Log Record Counter)是这套机制的串行号:定义在 Combined128 里,和 64 位 CurrBytePos 打包成 128 位,用 atomic_compare_and_swap_u128 一次原子推进。刷盘侧据 LRC 判断记录拷贝是否完成、顺序是否连续,从而在多线程下安全推进 flush 水位。</a:t>
             </a:r>
           </a:p>
         </p:txBody>
@@ -2144,17 +1602,20 @@
           <a:lstStyle/>
           <a:p>
             <a:r>
-              <a:t>检查点把内存中的脏数据成批落盘，并在控制文件里记下一个 redo point，使崩溃恢复只需从该点向后重放 WAL，而非从头开始。入口 CreateCheckPoint(12069) 先获取 WAL 插入位置算出 redo 点并写下 checkpoint 记录；核心刷盘委托给 CheckPointGuts(12726)，它按顺序刷 CLOG、CSNLOG、MultiXact、Predicate、RelationMap、ReplicationSlots 等子系统，再调 CheckPointBuffers(4978)。</a:t>
-            </a:r>
-          </a:p>
-          <a:p>
-            <a:r>
-              <a:t>CheckPointBuffers 根据是否增量检查点决定行为：非增量(USE_CKPT_THREAD_SYNC) 直接 BufferSync(4036) 刷全部脏页；增量且做全量检查点时，自身不刷页而是等待 pagewriter 线程刷够。BufferSync 扫描所有缓冲，对脏页打 BM_CHECKPOINT_NEEDED 标记后逐个 FlushBuffer，最终经 smgrwrite 分流：行存堆表走 mdwrite，段页式表走 seg_write。</a:t>
-            </a:r>
-          </a:p>
-          <a:p>
-            <a:r>
-              <a:t>文档 vs 开源 提醒：本页 doc 侧补充的预写式日志 GUC(wal_level、fsync、full_page_writes、checkpoint_segments) 与"Parallel Page-based Redo for Ustore(基于页的并行回放)"属 GaussDB 文档/概念层表述，用于解释配置与回放加速；它们不改变上图这条开源真实调用链，回放并行能力的具体实现以源码为准，不应把文档能力直接等同于开源 openGauss 代码路径。</a:t>
+              <a:rPr lang="zh-CN" dirty="0"/>
+              <a:t>检查点把内存脏数据成批落盘,并在控制文件里记一个 redo point,使崩溃恢复只需从该点向后重放 WAL,不必从头。入口 CreateCheckPoint 先取 WAL 插入位置算出 redo 点、写下 checkpoint 记录;核心刷盘委托给 CheckPointGuts,它依次刷 CLOG、CSNLOG、MultiXact、Predicate、RelationMap、ReplicationSlots 等子系统,再调 CheckPointBuffers。</a:t>
+            </a:r>
+          </a:p>
+          <a:p>
+            <a:r>
+              <a:rPr lang="zh-CN" dirty="0"/>
+              <a:t>CheckPointBuffers 看是否增量检查点:非增量直接 BufferSync 刷全部脏页;增量做全量时自身不刷、等 pagewriter 刷够。BufferSync 扫所有缓冲,给脏页打 BM_CHECKPOINT_NEEDED 后逐个 FlushBuffer,经 smgrwrite 分流——行存堆走 mdwrite,段页式走 seg_write。</a:t>
+            </a:r>
+          </a:p>
+          <a:p>
+            <a:r>
+              <a:rPr lang="zh-CN" dirty="0"/>
+              <a:t>文档 vs 开源提醒:doc 侧补充的 WAL GUC(wal_level、fsync、full_page_writes、checkpoint_segments)和'Parallel Page-based Redo for Ustore(基于页的并行回放)'属 GaussDB 文档/概念层,用来解释配置与回放加速;它们不改变上图这条开源真实调用链,并行回放的具体实现以源码为准,别把文档能力直接等同于开源代码路径。</a:t>
             </a:r>
           </a:p>
         </p:txBody>
@@ -2224,12 +1685,14 @@
           <a:lstStyle/>
           <a:p>
             <a:r>
-              <a:t>Astore（append-style heap）是 openGauss 兼容 PostgreSQL 的行存引擎。heap_insert 先用 heap_prepare_insert 填充元组头并按需 TOAST，再用 RelationGetBufferForTuple 找一个有空闲空间的页并钉住。进入临界区 START_CRIT_SECTION 后，RelationPutHeapTuple 把元组真正放进页内并写回 t_self（TID），MarkBufferDirty 把缓冲页标记为脏等待后台刷盘，最后构造 xl_heap_insert 并经 XLogBeginInsert/XLogInsert 写 WAL 保证崩溃可恢复。</a:t>
-            </a:r>
-          </a:p>
-          <a:p>
-            <a:r>
-              <a:t>关键特征：Astore 更新不原地修改旧版本——heap_update（5025 行）尽量用 HOT 链在同页串联新旧版本，heap_delete（4485 行）只在旧元组上打删除标记。因此旧元组会留在页里成为“死元组”，要等 VACUUM 才能真正回收空间，这正是 Astore 易膨胀、依赖 autovacuum 的根因，也是与下一页 Ustore 原位更新的核心差异。</a:t>
+              <a:rPr lang="zh-CN" dirty="0"/>
+              <a:t>Astore(append-style heap)是 openGauss 兼容 PostgreSQL 的行存引擎。heap_insert 先 heap_prepare_insert 填元组头、按需 TOAST,再 RelationGetBufferForTuple 找一个有空闲的页钉住。进临界区后 RelationPutHeapTuple 把元组放进页内、写回 t_self(TID),MarkBufferDirty 标脏等后台刷,最后构造 xl_heap_insert 经 XLogInsert 写 WAL 保证可恢复。</a:t>
+            </a:r>
+          </a:p>
+          <a:p>
+            <a:r>
+              <a:rPr lang="zh-CN" dirty="0"/>
+              <a:t>关键特征:Astore 更新不原地改旧版本——heap_update 尽量用 HOT 链在同页串联新旧版本,heap_delete 只在旧元组上打删除标记。于是旧元组留在页里成为'死元组',要等 VACUUM 才能真正回收空间。这正是 Astore 易膨胀、依赖 autovacuum 的根因,也是与下一页 Ustore 原位更新的核心差异。</a:t>
             </a:r>
           </a:p>
         </p:txBody>
@@ -2299,286 +1762,14 @@
           <a:lstStyle/>
           <a:p>
             <a:r>
-              <a:rPr dirty="0" err="1"/>
-              <a:t>Ustore（in-place</a:t>
-            </a:r>
-            <a:r>
-              <a:rPr dirty="0"/>
-              <a:t> update </a:t>
-            </a:r>
-            <a:r>
-              <a:rPr dirty="0" err="1"/>
-              <a:t>store）是</a:t>
-            </a:r>
-            <a:r>
-              <a:rPr dirty="0"/>
-              <a:t> </a:t>
-            </a:r>
-            <a:r>
-              <a:rPr dirty="0" err="1"/>
-              <a:t>openGauss</a:t>
-            </a:r>
-            <a:r>
-              <a:rPr dirty="0"/>
-              <a:t> </a:t>
-            </a:r>
-            <a:r>
-              <a:rPr dirty="0" err="1"/>
-              <a:t>的原位更新引擎，目标是抑制</a:t>
-            </a:r>
-            <a:r>
-              <a:rPr dirty="0"/>
-              <a:t> Astore </a:t>
-            </a:r>
-            <a:r>
-              <a:rPr dirty="0" err="1"/>
-              <a:t>的膨胀。UHeapInsert</a:t>
-            </a:r>
-            <a:r>
-              <a:rPr dirty="0"/>
-              <a:t> 先 </a:t>
-            </a:r>
-            <a:r>
-              <a:rPr dirty="0" err="1"/>
-              <a:t>UHeapPageReserveTransactionSlot</a:t>
-            </a:r>
-            <a:r>
-              <a:rPr dirty="0"/>
-              <a:t> </a:t>
-            </a:r>
-            <a:r>
-              <a:rPr dirty="0" err="1"/>
-              <a:t>在页内</a:t>
-            </a:r>
-            <a:r>
-              <a:rPr dirty="0"/>
-              <a:t> </a:t>
-            </a:r>
-            <a:r>
-              <a:rPr dirty="0" err="1"/>
-              <a:t>TD（Transaction</a:t>
-            </a:r>
-            <a:r>
-              <a:rPr dirty="0"/>
-              <a:t> </a:t>
-            </a:r>
-            <a:r>
-              <a:rPr dirty="0" err="1"/>
-              <a:t>Directory）目录中预留一个事务槽</a:t>
-            </a:r>
-            <a:r>
-              <a:rPr dirty="0"/>
-              <a:t>——TD </a:t>
-            </a:r>
-            <a:r>
-              <a:rPr dirty="0" err="1"/>
-              <a:t>槽数即</a:t>
-            </a:r>
-            <a:r>
-              <a:rPr dirty="0"/>
-              <a:t> UHeapPageHeaderData.td_count（knl_upage.h:260）。</a:t>
-            </a:r>
-            <a:r>
-              <a:rPr dirty="0" err="1"/>
-              <a:t>然后</a:t>
-            </a:r>
-            <a:r>
-              <a:rPr dirty="0"/>
-              <a:t> </a:t>
-            </a:r>
-            <a:r>
-              <a:rPr dirty="0" err="1"/>
-              <a:t>UHeapPrepareUndoInsert</a:t>
-            </a:r>
-            <a:r>
-              <a:rPr dirty="0"/>
-              <a:t> </a:t>
-            </a:r>
-            <a:r>
-              <a:rPr dirty="0" err="1"/>
-              <a:t>预分配</a:t>
-            </a:r>
-            <a:r>
-              <a:rPr dirty="0"/>
-              <a:t> undo </a:t>
-            </a:r>
-            <a:r>
-              <a:rPr dirty="0" err="1"/>
-              <a:t>空间得到</a:t>
-            </a:r>
-            <a:r>
-              <a:rPr dirty="0"/>
-              <a:t> </a:t>
-            </a:r>
-            <a:r>
-              <a:rPr dirty="0" err="1"/>
-              <a:t>urecPtr，把当前事务的</a:t>
-            </a:r>
-            <a:r>
-              <a:rPr dirty="0"/>
-              <a:t> </a:t>
-            </a:r>
-            <a:r>
-              <a:rPr dirty="0" err="1"/>
-              <a:t>prevUrecptr</a:t>
-            </a:r>
-            <a:r>
-              <a:rPr dirty="0"/>
-              <a:t> </a:t>
-            </a:r>
-            <a:r>
-              <a:rPr dirty="0" err="1"/>
-              <a:t>串进</a:t>
-            </a:r>
-            <a:r>
-              <a:rPr dirty="0"/>
-              <a:t> undo </a:t>
-            </a:r>
-            <a:r>
-              <a:rPr dirty="0" err="1"/>
-              <a:t>链。UHeapTupleHeaderSetTDSlot</a:t>
-            </a:r>
-            <a:r>
-              <a:rPr dirty="0"/>
-              <a:t> </a:t>
-            </a:r>
-            <a:r>
-              <a:rPr dirty="0" err="1"/>
-              <a:t>让磁盘元组记录所属</a:t>
-            </a:r>
-            <a:r>
-              <a:rPr dirty="0"/>
-              <a:t> TD </a:t>
-            </a:r>
-            <a:r>
-              <a:rPr dirty="0" err="1"/>
-              <a:t>槽号，配合</a:t>
-            </a:r>
-            <a:r>
-              <a:rPr dirty="0"/>
-              <a:t> UHeapTupleData（knl_utuple.h:168）——</a:t>
-            </a:r>
-            <a:r>
-              <a:rPr dirty="0" err="1"/>
-              <a:t>它通过</a:t>
-            </a:r>
-            <a:r>
-              <a:rPr dirty="0"/>
-              <a:t> TD </a:t>
-            </a:r>
-            <a:r>
-              <a:rPr dirty="0" err="1"/>
-              <a:t>槽而不是元组头里的</a:t>
-            </a:r>
-            <a:r>
-              <a:rPr dirty="0"/>
-              <a:t> XID </a:t>
-            </a:r>
-            <a:r>
-              <a:rPr dirty="0" err="1"/>
-              <a:t>来定位事务可见性信息，因此元组头更紧凑</a:t>
-            </a:r>
-            <a:r>
-              <a:rPr dirty="0"/>
-              <a:t>。</a:t>
-            </a:r>
-          </a:p>
-          <a:p>
-            <a:r>
-              <a:rPr dirty="0" err="1"/>
-              <a:t>RelationPutUTuple</a:t>
-            </a:r>
-            <a:r>
-              <a:rPr dirty="0"/>
-              <a:t> </a:t>
-            </a:r>
-            <a:r>
-              <a:rPr dirty="0" err="1"/>
-              <a:t>原地写入元组，UHeapPageSetUndo</a:t>
-            </a:r>
-            <a:r>
-              <a:rPr dirty="0"/>
-              <a:t> 把 TD </a:t>
-            </a:r>
-            <a:r>
-              <a:rPr dirty="0" err="1"/>
-              <a:t>槽指向</a:t>
-            </a:r>
-            <a:r>
-              <a:rPr dirty="0"/>
-              <a:t> undo </a:t>
-            </a:r>
-            <a:r>
-              <a:rPr dirty="0" err="1"/>
-              <a:t>记录，MarkBufferDirty</a:t>
-            </a:r>
-            <a:r>
-              <a:rPr dirty="0"/>
-              <a:t> </a:t>
-            </a:r>
-            <a:r>
-              <a:rPr dirty="0" err="1"/>
-              <a:t>标脏。原位更新意味着</a:t>
-            </a:r>
-            <a:r>
-              <a:rPr dirty="0"/>
-              <a:t> UPDATE </a:t>
-            </a:r>
-            <a:r>
-              <a:rPr dirty="0" err="1"/>
-              <a:t>时新值直接覆盖旧值，旧版本被搬进</a:t>
-            </a:r>
-            <a:r>
-              <a:rPr dirty="0"/>
-              <a:t> </a:t>
-            </a:r>
-            <a:r>
-              <a:rPr dirty="0" err="1"/>
-              <a:t>undo（见下一页</a:t>
-            </a:r>
-            <a:r>
-              <a:rPr dirty="0"/>
-              <a:t>），</a:t>
-            </a:r>
-            <a:r>
-              <a:rPr dirty="0" err="1"/>
-              <a:t>页内不再堆积死元组，从而显著降低膨胀、减轻对</a:t>
-            </a:r>
-            <a:r>
-              <a:rPr dirty="0"/>
-              <a:t> VACUUM </a:t>
-            </a:r>
-            <a:r>
-              <a:rPr dirty="0" err="1"/>
-              <a:t>的依赖。Ustore</a:t>
-            </a:r>
-            <a:r>
-              <a:rPr dirty="0"/>
-              <a:t> 是 </a:t>
-            </a:r>
-            <a:r>
-              <a:rPr dirty="0" err="1"/>
-              <a:t>openGauss</a:t>
-            </a:r>
-            <a:r>
-              <a:rPr dirty="0"/>
-              <a:t> </a:t>
-            </a:r>
-            <a:r>
-              <a:rPr dirty="0" err="1"/>
-              <a:t>默认推荐的</a:t>
-            </a:r>
-            <a:r>
-              <a:rPr dirty="0"/>
-              <a:t> OLTP </a:t>
-            </a:r>
-            <a:r>
-              <a:rPr dirty="0" err="1"/>
-              <a:t>行存引擎</a:t>
-            </a:r>
-            <a:r>
-              <a:rPr dirty="0"/>
-              <a:t>。</a:t>
+              <a:rPr lang="zh-CN" dirty="0"/>
+              <a:t>Ustore(in-place update store)是 openGauss 的原位更新引擎,目标是抑制 Astore 的膨胀。UHeapInsert 先 UHeapPageReserveTransactionSlot 在页内 TD(事务目录)预留一个事务槽——TD 槽数即 UHeapPageHeaderData.td_count。再 UHeapPrepareUndoInsert 预分配 undo 得到 urecPtr,把当前事务的 prevUrecptr 串进 undo 链。UHeapTupleHeaderSetTDSlot 让磁盘元组记录所属 TD 槽号——可见性信息靠 TD 槽而非元组头里的 XID 定位,所以元组头更紧凑。</a:t>
+            </a:r>
+          </a:p>
+          <a:p>
+            <a:r>
+              <a:rPr lang="zh-CN" dirty="0"/>
+              <a:t>RelationPutUTuple 原地写入元组,UHeapPageSetUndo 把 TD 槽指向 undo 记录,MarkBufferDirty 标脏。原位更新意味着 UPDATE 时新值直接覆盖旧值,旧版本搬进 undo(见下一页),页内不再堆积死元组,从而显著降低膨胀、减轻对 VACUUM 的依赖。Ustore 是 openGauss 默认推荐的 OLTP 行存引擎。</a:t>
             </a:r>
           </a:p>
         </p:txBody>
@@ -2648,17 +1839,20 @@
           <a:lstStyle/>
           <a:p>
             <a:r>
-              <a:t>Ustore 的多版本并发控制靠 undo 子系统实现，模块分布在 knl_uundoapi / knl_uundozone / knl_uundorecycle / knl_uundospace / knl_uundotxn / knl_uundoxlog 等文件中。更新路径上，UHeapUpdate 先 UHeapPrepareUndoUpdate 组织本次更新的 undo 记录，再由 UndoRecord::Prepare（knl_uundorecord.cpp:264）按 RecordSize 用 AdvanceUndoPtr 在 undo 空间里“预留”一段位置并返回 urp_，PrepareUndoMeta 登记元数据；随后 RelationPutUTuple 原地把新版本写回数据页、MarkBufferDirty 标脏、XLogInsert 落 WAL。旧版本被保存在 undo 里。</a:t>
-            </a:r>
-          </a:p>
-          <a:p>
-            <a:r>
-              <a:t>读快照需要旧版本时，FetchUndoRecord（knl_uundorecord.cpp:524）按 blkno/offset/xid 沿 undo 链 LoadUndoRecord 逐条回溯，重建出某个历史快照对应的元组版本——这就是 Ustore 的版本重建。</a:t>
-            </a:r>
-          </a:p>
-          <a:p>
-            <a:r>
-              <a:t>文档 vs 开源差异（务必标注）：所谓 RCR（Row Consistency Read）术语在开源 6.0.0 主要出现在 ubtree 索引层（如 UBTREE_OPAQUE_VERSION_RCR），uheap 代码本身并不含 “RCR” 字串，属文档用词，不要把它当作 uheap 源码概念。另外，对比 Astore：Astore 旧版本留在数据页、靠 VACUUM 异步回收（易膨胀）；Ustore 旧版本进 undo、由 undo recycle（knl_uundorecycle）按事务可见性回收，二者的空间回收机制本质不同。</a:t>
+              <a:rPr lang="zh-CN" dirty="0"/>
+              <a:t>Ustore 的 MVCC 靠 undo 子系统,模块分布在 knl_uundoapi/uundozone/uundorecycle/uundospace/uundotxn/uundoxlog 等文件。更新路径上,UHeapUpdate 先 UHeapPrepareUndoUpdate 组织本次 undo 记录,再由 UndoRecord::Prepare 按 RecordSize 用 AdvanceUndoPtr 在 undo 空间预留一段、返回 urp_,PrepareUndoMeta 登记元数据;随后 RelationPutUTuple 原地写新版本、MarkBufferDirty 标脏、XLogInsert 落 WAL。旧版本保存在 undo 里。</a:t>
+            </a:r>
+          </a:p>
+          <a:p>
+            <a:r>
+              <a:rPr lang="zh-CN" dirty="0"/>
+              <a:t>读快照需要旧版本时,FetchUndoRecord 按 blkno/offset/xid 沿 undo 链 LoadUndoRecord 逐条回溯,重建某个历史快照对应的元组版本——这就是 Ustore 的版本重建。</a:t>
+            </a:r>
+          </a:p>
+          <a:p>
+            <a:r>
+              <a:rPr lang="zh-CN" dirty="0"/>
+              <a:t>文档 vs 开源差异(务必标注):所谓 RCR(Row Consistency Read)在开源 6.0.0 主要出现在 ubtree 索引层(如 UBTREE_OPAQUE_VERSION_RCR),uheap 代码本身不含 'RCR' 字串,属文档用词,别当成 uheap 源码概念。再对比 Astore:Astore 旧版本留页内、靠 VACUUM 异步回收(易膨胀);Ustore 旧版本进 undo、由 undo recycle 按事务可见性回收,二者空间回收机制本质不同。</a:t>
             </a:r>
           </a:p>
         </p:txBody>
@@ -2811,12 +2005,14 @@
           <a:lstStyle/>
           <a:p>
             <a:r>
-              <a:t>这页是全场的"打假与对齐"表, 目的是防止把开源 openGauss 6.0.0 直接当成 GaussDB 商业版来讲。前 10 行都能在源码里找到对应文件/GUC, 我已逐一核对路径存在:Ustore、UBTree(RCR)、Undo、Global SysCache、Global Plan Cache、ADIO 开关、段页式、NUMA、cstore_buffers、MOT(编译可选)。</a:t>
-            </a:r>
-          </a:p>
-          <a:p>
-            <a:r>
-              <a:t>最后三行是必须标红的差异点。Enhanced Toast 在开源 6.0.0 找不到实现, 开源只有标准 PostgreSQL 的 TOAST, 属 GaussDB 专有增强。所谓"去双写"被明显夸大:开源里 double_write 依旧存在, dw_enabled() 仍是开关, 段页式表落盘还会调 seg_dw_single_flush; ADIO 只是另一条由 enable_adio_function 控制的直接 IO 路径, 是适配而非移除双写。Global PL/SQL Cache 在开源里只覆盖 package 运行时缓存这一小块, 远窄于文档描述。讲到这三行时一定要口头点明"文档 vs 开源"的边界。</a:t>
+              <a:rPr lang="zh-CN" dirty="0"/>
+              <a:t>这页是全场的'打假与对齐'表,防止把开源 openGauss 6.0.0 直接当成 GaussDB 商业版讲。前 10 行都能在源码里找到对应文件/GUC,我已逐一核对路径存在:Ustore、UBTree(RCR)、Undo、Global SysCache、Global Plan Cache、ADIO 开关、段页式、NUMA、cstore_buffers、MOT(编译可选)。</a:t>
+            </a:r>
+          </a:p>
+          <a:p>
+            <a:r>
+              <a:rPr lang="zh-CN" dirty="0"/>
+              <a:t>最后三行必须标红。Enhanced Toast 在开源 6.0.0 找不到实现,开源只有标准 PostgreSQL 的 TOAST,属 GaussDB 专有增强。所谓'去双写'明显夸大:开源里 double_write 依旧存在,dw_enabled() 仍是开关,段页式落盘还会调 seg_dw_single_flush;ADIO 只是另一条由 enable_adio_function 控制的直接 IO 路径,是适配不是移除双写。Global PL/SQL Cache 在开源里只覆盖 package 运行时缓存这一小块,远窄于文档描述。讲到这三行,一定口头点明'文档 vs 开源'的边界。</a:t>
             </a:r>
           </a:p>
         </p:txBody>
@@ -2886,278 +2082,14 @@
           <a:lstStyle/>
           <a:p>
             <a:r>
-              <a:rPr dirty="0" err="1"/>
-              <a:t>收尾页用三到五条把全程主线再串一遍。第一条复述缓冲管理:入口</a:t>
-            </a:r>
-            <a:r>
-              <a:rPr dirty="0"/>
-              <a:t> </a:t>
-            </a:r>
-            <a:r>
-              <a:rPr dirty="0" err="1"/>
-              <a:t>ReadBuffer</a:t>
-            </a:r>
-            <a:r>
-              <a:rPr dirty="0"/>
-              <a:t> 经 </a:t>
-            </a:r>
-            <a:r>
-              <a:rPr dirty="0" err="1"/>
-              <a:t>BufferAlloc</a:t>
-            </a:r>
-            <a:r>
-              <a:rPr dirty="0"/>
-              <a:t> </a:t>
-            </a:r>
-            <a:r>
-              <a:rPr dirty="0" err="1"/>
-              <a:t>查共享哈希表</a:t>
-            </a:r>
-            <a:r>
-              <a:rPr dirty="0"/>
-              <a:t>, </a:t>
-            </a:r>
-            <a:r>
-              <a:rPr dirty="0" err="1"/>
-              <a:t>命中直接</a:t>
-            </a:r>
-            <a:r>
-              <a:rPr dirty="0"/>
-              <a:t> pin, </a:t>
-            </a:r>
-            <a:r>
-              <a:rPr dirty="0" err="1"/>
-              <a:t>未命中用时钟</a:t>
-            </a:r>
-            <a:r>
-              <a:rPr dirty="0"/>
-              <a:t>(clock-sweep)</a:t>
-            </a:r>
-            <a:r>
-              <a:rPr dirty="0" err="1"/>
-              <a:t>算法选淘汰页</a:t>
-            </a:r>
-            <a:r>
-              <a:rPr dirty="0"/>
-              <a:t>, </a:t>
-            </a:r>
-            <a:r>
-              <a:rPr dirty="0" err="1"/>
-              <a:t>脏页要先</a:t>
-            </a:r>
-            <a:r>
-              <a:rPr dirty="0"/>
-              <a:t> </a:t>
-            </a:r>
-            <a:r>
-              <a:rPr dirty="0" err="1"/>
-              <a:t>FlushBuffer</a:t>
-            </a:r>
-            <a:r>
-              <a:rPr dirty="0"/>
-              <a:t>; </a:t>
-            </a:r>
-            <a:r>
-              <a:rPr dirty="0" err="1"/>
-              <a:t>状态机围绕</a:t>
-            </a:r>
-            <a:r>
-              <a:rPr dirty="0"/>
-              <a:t> </a:t>
-            </a:r>
-            <a:r>
-              <a:rPr dirty="0" err="1"/>
-              <a:t>BM_DIRTY、pin</a:t>
-            </a:r>
-            <a:r>
-              <a:rPr dirty="0"/>
-              <a:t> </a:t>
-            </a:r>
-            <a:r>
-              <a:rPr dirty="0" err="1"/>
-              <a:t>count、usage</a:t>
-            </a:r>
-            <a:r>
-              <a:rPr dirty="0"/>
-              <a:t> count </a:t>
-            </a:r>
-            <a:r>
-              <a:rPr dirty="0" err="1"/>
-              <a:t>运转。第二条复述持久化:WAL</a:t>
-            </a:r>
-            <a:r>
-              <a:rPr dirty="0"/>
-              <a:t> </a:t>
-            </a:r>
-            <a:r>
-              <a:rPr dirty="0" err="1"/>
-              <a:t>先行保证已提交不丢</a:t>
-            </a:r>
-            <a:r>
-              <a:rPr dirty="0"/>
-              <a:t>, </a:t>
-            </a:r>
-            <a:r>
-              <a:rPr dirty="0" err="1"/>
-              <a:t>检查点周期性把脏页经</a:t>
-            </a:r>
-            <a:r>
-              <a:rPr dirty="0"/>
-              <a:t> </a:t>
-            </a:r>
-            <a:r>
-              <a:rPr dirty="0" err="1"/>
-              <a:t>smgr</a:t>
-            </a:r>
-            <a:r>
-              <a:rPr dirty="0"/>
-              <a:t> </a:t>
-            </a:r>
-            <a:r>
-              <a:rPr dirty="0" err="1"/>
-              <a:t>写盘</a:t>
-            </a:r>
-            <a:r>
-              <a:rPr dirty="0"/>
-              <a:t>, </a:t>
-            </a:r>
-            <a:r>
-              <a:rPr dirty="0" err="1"/>
-              <a:t>mdwrite</a:t>
-            </a:r>
-            <a:r>
-              <a:rPr dirty="0"/>
-              <a:t> </a:t>
-            </a:r>
-            <a:r>
-              <a:rPr dirty="0" err="1"/>
-              <a:t>走普通堆、seg_write</a:t>
-            </a:r>
-            <a:r>
-              <a:rPr dirty="0"/>
-              <a:t> </a:t>
-            </a:r>
-            <a:r>
-              <a:rPr dirty="0" err="1"/>
-              <a:t>走段页式</a:t>
-            </a:r>
-            <a:r>
-              <a:rPr dirty="0"/>
-              <a:t>, double-write </a:t>
-            </a:r>
-            <a:r>
-              <a:rPr dirty="0" err="1"/>
-              <a:t>防止半页写坏</a:t>
-            </a:r>
-            <a:r>
-              <a:rPr dirty="0"/>
-              <a:t>(torn page)。</a:t>
-            </a:r>
-          </a:p>
-          <a:p>
-            <a:r>
-              <a:rPr dirty="0" err="1"/>
-              <a:t>第三条是两主题的缝合点</a:t>
-            </a:r>
-            <a:r>
-              <a:rPr dirty="0"/>
-              <a:t>, </a:t>
-            </a:r>
-            <a:r>
-              <a:rPr dirty="0" err="1"/>
-              <a:t>即上一张</a:t>
-            </a:r>
-            <a:r>
-              <a:rPr dirty="0"/>
-              <a:t> UPDATE </a:t>
-            </a:r>
-            <a:r>
-              <a:rPr dirty="0" err="1"/>
-              <a:t>流程图的文字版:改内存</a:t>
-            </a:r>
-            <a:r>
-              <a:rPr dirty="0"/>
-              <a:t> + </a:t>
-            </a:r>
-            <a:r>
-              <a:rPr dirty="0" err="1"/>
-              <a:t>写日志</a:t>
-            </a:r>
-            <a:r>
-              <a:rPr dirty="0"/>
-              <a:t> -&gt; </a:t>
-            </a:r>
-            <a:r>
-              <a:rPr dirty="0" err="1"/>
-              <a:t>提交只</a:t>
-            </a:r>
-            <a:r>
-              <a:rPr dirty="0"/>
-              <a:t> flush </a:t>
-            </a:r>
-            <a:r>
-              <a:rPr dirty="0" err="1"/>
-              <a:t>日志</a:t>
-            </a:r>
-            <a:r>
-              <a:rPr dirty="0"/>
-              <a:t> -&gt; </a:t>
-            </a:r>
-            <a:r>
-              <a:rPr dirty="0" err="1"/>
-              <a:t>检查点异步刷数据页</a:t>
-            </a:r>
-            <a:r>
-              <a:rPr dirty="0"/>
-              <a:t> -&gt; </a:t>
-            </a:r>
-            <a:r>
-              <a:rPr dirty="0" err="1"/>
-              <a:t>崩溃靠</a:t>
-            </a:r>
-            <a:r>
-              <a:rPr dirty="0"/>
-              <a:t> WAL </a:t>
-            </a:r>
-            <a:r>
-              <a:rPr dirty="0" err="1"/>
-              <a:t>重放。第四条再次强调保真度边界</a:t>
-            </a:r>
-            <a:r>
-              <a:rPr dirty="0"/>
-              <a:t>, </a:t>
-            </a:r>
-            <a:r>
-              <a:rPr dirty="0" err="1"/>
-              <a:t>呼应对照表的三个商业增强差异</a:t>
-            </a:r>
-            <a:r>
-              <a:rPr dirty="0"/>
-              <a:t>, </a:t>
-            </a:r>
-            <a:r>
-              <a:rPr dirty="0" err="1"/>
-              <a:t>避免听众把开源当商业版。最后一条给出可复现的引用坐标:具体</a:t>
-            </a:r>
-            <a:r>
-              <a:rPr dirty="0"/>
-              <a:t> commit </a:t>
-            </a:r>
-            <a:r>
-              <a:rPr dirty="0" err="1"/>
-              <a:t>号、源码根目录、以及文档版本章节</a:t>
-            </a:r>
-            <a:r>
-              <a:rPr dirty="0"/>
-              <a:t>, </a:t>
-            </a:r>
-            <a:r>
-              <a:rPr dirty="0" err="1"/>
-              <a:t>方便课后按图索骥核对每一处</a:t>
-            </a:r>
-            <a:r>
-              <a:rPr dirty="0"/>
-              <a:t> file:line。</a:t>
+              <a:rPr lang="zh-CN" dirty="0"/>
+              <a:t>收尾页用三到五条把全程主线再串一遍。第一条复述缓冲管理:入口 ReadBuffer 经 BufferAlloc 查共享哈希表,命中直接 pin,未命中用时钟(clock-sweep)选淘汰页,脏页先 FlushBuffer;状态机围绕 BM_DIRTY、pin count、usage count 运转。第二条复述持久化:WAL 先行保证已提交不丢,检查点周期性把脏页经 smgr 写盘——mdwrite 走普通堆、seg_write 走段页式,double-write 防半页写坏(torn page)。</a:t>
+            </a:r>
+          </a:p>
+          <a:p>
+            <a:r>
+              <a:rPr lang="zh-CN" dirty="0"/>
+              <a:t>第三条是两主题的缝合点,即上一张 UPDATE 流程图的文字版:改内存 + 写日志 → 提交只 flush 日志 → 检查点异步刷数据页 → 崩溃靠 WAL 重放。第四条再强调保真度边界,呼应对照表的三个商业增强差异,别让听众把开源当商业版。最后一条给可复现的引用坐标:具体 commit 号、源码根目录、文档版本章节,方便课后按图索骥核对每处 file:line。</a:t>
             </a:r>
           </a:p>
         </p:txBody>
@@ -3227,342 +2159,26 @@
           <a:lstStyle/>
           <a:p>
             <a:r>
-              <a:rPr dirty="0" err="1"/>
-              <a:t>这页是全讲的地图</a:t>
-            </a:r>
-            <a:r>
-              <a:rPr dirty="0"/>
-              <a:t>: </a:t>
-            </a:r>
-            <a:r>
-              <a:rPr dirty="0" err="1"/>
-              <a:t>数据从</a:t>
-            </a:r>
-            <a:r>
-              <a:rPr dirty="0"/>
-              <a:t> SQL </a:t>
-            </a:r>
-            <a:r>
-              <a:rPr dirty="0" err="1"/>
-              <a:t>到磁盘要穿过四个主层</a:t>
-            </a:r>
-            <a:r>
-              <a:rPr dirty="0"/>
-              <a:t>, </a:t>
-            </a:r>
-            <a:r>
-              <a:rPr dirty="0" err="1"/>
-              <a:t>外加三个旁路子系统</a:t>
-            </a:r>
-            <a:r>
-              <a:rPr dirty="0"/>
-              <a:t>。</a:t>
-            </a:r>
-          </a:p>
-          <a:p>
-            <a:r>
-              <a:rPr dirty="0" err="1"/>
-              <a:t>自顶向下</a:t>
-            </a:r>
-            <a:r>
-              <a:rPr dirty="0"/>
-              <a:t>: </a:t>
-            </a:r>
-            <a:r>
-              <a:rPr dirty="0" err="1"/>
-              <a:t>访问方法层</a:t>
-            </a:r>
-            <a:r>
-              <a:rPr dirty="0"/>
-              <a:t> (heap/Astore 与 </a:t>
-            </a:r>
-            <a:r>
-              <a:rPr dirty="0" err="1"/>
-              <a:t>uheap</a:t>
-            </a:r>
-            <a:r>
-              <a:rPr dirty="0"/>
-              <a:t>/</a:t>
-            </a:r>
-            <a:r>
-              <a:rPr dirty="0" err="1"/>
-              <a:t>Ustore</a:t>
-            </a:r>
-            <a:r>
-              <a:rPr dirty="0"/>
-              <a:t>) </a:t>
-            </a:r>
-            <a:r>
-              <a:rPr dirty="0" err="1"/>
-              <a:t>只认元组与页面</a:t>
-            </a:r>
-            <a:r>
-              <a:rPr dirty="0"/>
-              <a:t>, </a:t>
-            </a:r>
-            <a:r>
-              <a:rPr dirty="0" err="1"/>
-              <a:t>把"页面在哪、是否在内存"完全委托给下一层</a:t>
-            </a:r>
-            <a:r>
-              <a:rPr dirty="0"/>
-              <a:t>;</a:t>
-            </a:r>
-          </a:p>
-          <a:p>
-            <a:r>
-              <a:rPr dirty="0" err="1"/>
-              <a:t>缓存层</a:t>
-            </a:r>
-            <a:r>
-              <a:rPr dirty="0"/>
-              <a:t> Buffer Pool </a:t>
-            </a:r>
-            <a:r>
-              <a:rPr dirty="0" err="1"/>
-              <a:t>是核心</a:t>
-            </a:r>
-            <a:r>
-              <a:rPr dirty="0"/>
-              <a:t>, bufmgr.cpp </a:t>
-            </a:r>
-            <a:r>
-              <a:rPr dirty="0" err="1"/>
-              <a:t>负责命中判定与缺页装入</a:t>
-            </a:r>
-            <a:r>
-              <a:rPr dirty="0"/>
-              <a:t>, freelist.cpp </a:t>
-            </a:r>
-            <a:r>
-              <a:rPr dirty="0" err="1"/>
-              <a:t>负责挑选可淘汰的</a:t>
-            </a:r>
-            <a:r>
-              <a:rPr dirty="0"/>
-              <a:t> victim; </a:t>
-            </a:r>
-            <a:r>
-              <a:rPr dirty="0" err="1"/>
-              <a:t>几乎所有读写都从这里过</a:t>
-            </a:r>
-            <a:r>
-              <a:rPr dirty="0"/>
-              <a:t>。</a:t>
-            </a:r>
-          </a:p>
-          <a:p>
-            <a:r>
-              <a:rPr dirty="0" err="1"/>
-              <a:t>再往下</a:t>
-            </a:r>
-            <a:r>
-              <a:rPr dirty="0"/>
-              <a:t> SMGR (smgr.cpp) </a:t>
-            </a:r>
-            <a:r>
-              <a:rPr dirty="0" err="1"/>
-              <a:t>是存储管理抽象</a:t>
-            </a:r>
-            <a:r>
-              <a:rPr dirty="0"/>
-              <a:t>, </a:t>
-            </a:r>
-            <a:r>
-              <a:rPr dirty="0" err="1"/>
-              <a:t>它用一张函数表把"逻辑</a:t>
-            </a:r>
-            <a:r>
-              <a:rPr dirty="0"/>
-              <a:t> </a:t>
-            </a:r>
-            <a:r>
-              <a:rPr dirty="0" err="1"/>
-              <a:t>relation"映射到物理实现</a:t>
-            </a:r>
-            <a:r>
-              <a:rPr dirty="0"/>
-              <a:t>: </a:t>
-            </a:r>
-            <a:r>
-              <a:rPr dirty="0" err="1"/>
-              <a:t>普通表落到</a:t>
-            </a:r>
-            <a:r>
-              <a:rPr dirty="0"/>
-              <a:t> md.cpp </a:t>
-            </a:r>
-            <a:r>
-              <a:rPr dirty="0" err="1"/>
-              <a:t>管理的物理文件</a:t>
-            </a:r>
-            <a:r>
-              <a:rPr dirty="0"/>
-              <a:t>, </a:t>
-            </a:r>
-            <a:r>
-              <a:rPr dirty="0" err="1"/>
-              <a:t>段页式表落到</a:t>
-            </a:r>
-            <a:r>
-              <a:rPr dirty="0"/>
-              <a:t> segment/ </a:t>
-            </a:r>
-            <a:r>
-              <a:rPr dirty="0" err="1"/>
-              <a:t>目录的实现</a:t>
-            </a:r>
-            <a:r>
-              <a:rPr dirty="0"/>
-              <a:t>; </a:t>
-            </a:r>
-            <a:r>
-              <a:rPr dirty="0" err="1"/>
-              <a:t>最底层才是真正的文件系统读写与可选的</a:t>
-            </a:r>
-            <a:r>
-              <a:rPr dirty="0"/>
-              <a:t> CFS </a:t>
-            </a:r>
-            <a:r>
-              <a:rPr dirty="0" err="1"/>
-              <a:t>压缩</a:t>
-            </a:r>
-            <a:r>
-              <a:rPr dirty="0"/>
-              <a:t>。</a:t>
-            </a:r>
-          </a:p>
-          <a:p>
-            <a:r>
-              <a:rPr dirty="0" err="1"/>
-              <a:t>右侧旁路不在主读路径上但同样关键</a:t>
-            </a:r>
-            <a:r>
-              <a:rPr dirty="0"/>
-              <a:t>: WAL(</a:t>
-            </a:r>
-            <a:r>
-              <a:rPr dirty="0" err="1"/>
-              <a:t>xlog</a:t>
-            </a:r>
-            <a:r>
-              <a:rPr dirty="0"/>
-              <a:t>) </a:t>
-            </a:r>
-            <a:r>
-              <a:rPr dirty="0" err="1"/>
-              <a:t>保证崩溃可恢复</a:t>
-            </a:r>
-            <a:r>
-              <a:rPr dirty="0"/>
-              <a:t>, Undo </a:t>
-            </a:r>
-            <a:r>
-              <a:rPr dirty="0" err="1"/>
-              <a:t>支撑</a:t>
-            </a:r>
-            <a:r>
-              <a:rPr dirty="0"/>
-              <a:t> </a:t>
-            </a:r>
-            <a:r>
-              <a:rPr dirty="0" err="1"/>
-              <a:t>Ustore</a:t>
-            </a:r>
-            <a:r>
-              <a:rPr dirty="0"/>
-              <a:t> </a:t>
-            </a:r>
-            <a:r>
-              <a:rPr dirty="0" err="1"/>
-              <a:t>的就地更新多版本</a:t>
-            </a:r>
-            <a:r>
-              <a:rPr dirty="0"/>
-              <a:t>, </a:t>
-            </a:r>
-            <a:r>
-              <a:rPr dirty="0" err="1"/>
-              <a:t>检查点借</a:t>
-            </a:r>
-            <a:r>
-              <a:rPr dirty="0"/>
-              <a:t> </a:t>
-            </a:r>
-            <a:r>
-              <a:rPr dirty="0" err="1"/>
-              <a:t>pagewriter</a:t>
-            </a:r>
-            <a:r>
-              <a:rPr dirty="0"/>
-              <a:t> </a:t>
-            </a:r>
-            <a:r>
-              <a:rPr dirty="0" err="1"/>
-              <a:t>把脏页成批刷盘以推进</a:t>
-            </a:r>
-            <a:r>
-              <a:rPr dirty="0"/>
-              <a:t> redo </a:t>
-            </a:r>
-            <a:r>
-              <a:rPr dirty="0" err="1"/>
-              <a:t>起点</a:t>
-            </a:r>
-            <a:r>
-              <a:rPr dirty="0"/>
-              <a:t>。</a:t>
-            </a:r>
-          </a:p>
-          <a:p>
-            <a:r>
-              <a:rPr dirty="0" err="1"/>
-              <a:t>注意</a:t>
-            </a:r>
-            <a:r>
-              <a:rPr dirty="0"/>
-              <a:t> Astore/</a:t>
-            </a:r>
-            <a:r>
-              <a:rPr dirty="0" err="1"/>
-              <a:t>Ustore</a:t>
-            </a:r>
-            <a:r>
-              <a:rPr dirty="0"/>
-              <a:t> </a:t>
-            </a:r>
-            <a:r>
-              <a:rPr dirty="0" err="1"/>
-              <a:t>都是开源真实存在的访问方法</a:t>
-            </a:r>
-            <a:r>
-              <a:rPr dirty="0"/>
-              <a:t>; 而 Enhanced Toast 属 </a:t>
-            </a:r>
-            <a:r>
-              <a:rPr dirty="0" err="1"/>
-              <a:t>GaussDB</a:t>
-            </a:r>
-            <a:r>
-              <a:rPr dirty="0"/>
-              <a:t> </a:t>
-            </a:r>
-            <a:r>
-              <a:rPr dirty="0" err="1"/>
-              <a:t>专有</a:t>
-            </a:r>
-            <a:r>
-              <a:rPr dirty="0"/>
-              <a:t>, </a:t>
-            </a:r>
-            <a:r>
-              <a:rPr dirty="0" err="1"/>
-              <a:t>不在本图开源层中</a:t>
-            </a:r>
-            <a:r>
-              <a:rPr dirty="0"/>
-              <a:t>。</a:t>
+              <a:rPr lang="zh-CN" dirty="0"/>
+              <a:t>这页是全讲的地图:数据从 SQL 到磁盘要穿过四个主层,外加三个旁路子系统。</a:t>
+            </a:r>
+          </a:p>
+          <a:p>
+            <a:r>
+              <a:rPr lang="zh-CN" dirty="0"/>
+              <a:t>自顶向下——访问方法层(heap/Astore、uheap/Ustore)只认元组和页面,把'页在哪、是否在内存'交给下一层;缓存层 Buffer Pool 是核心,bufmgr.cpp 判命中、装缺页,freelist.cpp 挑淘汰页,几乎所有读写都过这里。</a:t>
+            </a:r>
+          </a:p>
+          <a:p>
+            <a:r>
+              <a:rPr lang="zh-CN" dirty="0"/>
+              <a:t>再往下 SMGR(smgr.cpp)是存储抽象,用函数表把逻辑 relation 映射到物理实现:普通表落 md.cpp,段页式落 segment/;最底层才是文件读写和可选的 CFS 压缩。</a:t>
+            </a:r>
+          </a:p>
+          <a:p>
+            <a:r>
+              <a:rPr lang="zh-CN" dirty="0"/>
+              <a:t>右侧三条旁路不在主读路径,但同样关键:WAL 保证崩溃可恢复,Undo 支撑 Ustore 就地更新的多版本,检查点借 pagewriter 批量刷脏页、推进 redo 起点。提一句:Astore、Ustore 是开源真实存在的;Enhanced Toast 属 GaussDB 专有,不在本图开源层里。</a:t>
             </a:r>
           </a:p>
         </p:txBody>
@@ -3632,32 +2248,26 @@
           <a:lstStyle/>
           <a:p>
             <a:r>
-              <a:t>这页把上一张地图里的"缓存层 -&gt; SMGR -&gt; 磁盘"放大成一条真实函数调用链, 全部经过验证的 file:line。</a:t>
-            </a:r>
-          </a:p>
-          <a:p>
-            <a:r>
-              <a:t>入口是 ReadBuffer(1661), 它转调 ReadBufferExtended, 再进入核心的 ReadBuffer_common(2568); 真正的页面定位与分配在 BufferAlloc(3047) 内完成。</a:t>
-            </a:r>
-          </a:p>
-          <a:p>
-            <a:r>
-              <a:t>BufferAlloc 先用 BufTableLookup(3078) 在共享缓冲哈希表里查 (relfilenode, fork, block) 这个 tag: 命中就直接复用并 pin 住返回, 统计落到 shared_blks_hit, 整条路径不触盘, 这是最快的热路径。</a:t>
-            </a:r>
-          </a:p>
-          <a:p>
-            <a:r>
-              <a:t>未命中时调用 StrategyGetBuffer(3159) 按时钟/freelist 策略挑一个 victim 槽位; 如果这个 victim 当前是脏页, 必须先 FlushBuffer(5176) 把它的旧内容写回磁盘, 腾干净后才能复用。</a:t>
-            </a:r>
-          </a:p>
-          <a:p>
-            <a:r>
-              <a:t>腾好槽位后, ReadBuffer_common 调用 smgrread(2141), 经 SMGR 函数表落到普通表的 mdread (或段页式的 segment 读), 把目标块从磁盘装进缓冲页, 最后返回 Buffer 句柄给访问方法层。</a:t>
-            </a:r>
-          </a:p>
-          <a:p>
-            <a:r>
-              <a:t>写路径与之对称: 上层改完页调用 MarkBufferDirty 置脏, 不立即落盘, 而由后台 BgWriter/pagewriter 或检查点异步 FlushBuffer; 落盘前 WAL 必须先写, 这就是 WAL 旁路保证崩溃可恢复的原因。</a:t>
+              <a:rPr lang="zh-CN" dirty="0"/>
+              <a:t>这页把'缓存层 → SMGR → 磁盘'放大成一条真实函数调用链,都是验证过的 file:line。</a:t>
+            </a:r>
+          </a:p>
+          <a:p>
+            <a:r>
+              <a:rPr lang="zh-CN" dirty="0"/>
+              <a:t>入口 ReadBuffer 转 ReadBufferExtended,进核心 ReadBuffer_common;页面定位和分配在 BufferAlloc 里完成。BufferAlloc 先用 BufTableLookup 在共享哈希表查 (relfilenode, fork, block):命中就复用、pin 住返回,计入 shared_blks_hit,不触盘——这是最快的热路径。</a:t>
+            </a:r>
+          </a:p>
+          <a:p>
+            <a:r>
+              <a:rPr lang="zh-CN" dirty="0"/>
+              <a:t>未命中就 StrategyGetBuffer 按时钟/freelist 挑 victim;victim 若是脏页,得先 FlushBuffer 写回再复用。腾好后 smgrread 经 SMGR 落到 mdread 或段页式读,把块装进缓冲页,返回句柄。</a:t>
+            </a:r>
+          </a:p>
+          <a:p>
+            <a:r>
+              <a:rPr lang="zh-CN" dirty="0"/>
+              <a:t>写路径对称:改完页 MarkBufferDirty 置脏,不立即落盘,由后台 BgWriter/pagewriter 或检查点异步刷;落盘前 WAL 必须先写——这就是崩溃可恢复的保证。</a:t>
             </a:r>
           </a:p>
         </p:txBody>
@@ -3727,7 +2337,20 @@
           <a:lstStyle/>
           <a:p>
             <a:r>
-              <a:t>InitBufferPool 在共享内存初始化阶段(postmaster 或单机后端)只调用一次。它先用 ShmemInitStruct 申请 BufferDescriptors 数组，长度 TOTAL_BUFFER_NUM 个 BufferDescPadded，并做 CACHELINEALIGN 缓存行对齐以降低并发争用。随后申请 BufferBlocks，大小为 (TOTAL_BUFFER_NUM - NVM_BUFFER_NUM) * BLCKSZ，即每个普通缓冲页占 8KB。两者按下标对齐：第 i 个 BufferDesc 描述 BufferBlocks 中第 i 个数据块。结构体定义见 buf_internals.h:215 BufferDesc(含 tag、state 原子量、buf_id、content_lock 等) 和 buf_internals.h:98 BufferTag。BufferTag 内嵌 RelFileNode rnode(spcNode 表空间/dbNode 库/relNode 关系) 加 forkNum、blockNum，正是后续哈希表的查找键。这里 NBuffers 由 GUC shared_buffers 换算而来，是整个缓冲管理的容量基准。</a:t>
+              <a:rPr lang="zh-CN" dirty="0"/>
+              <a:t>InitBufferPool 在共享内存初始化阶段只调一次。先 ShmemInitStruct 申请 BufferDescriptors 数组,长度 TOTAL_BUFFER_NUM,做缓存行对齐降低并发争用;再申请 BufferBlocks,每个普通缓冲页 8KB。</a:t>
+            </a:r>
+          </a:p>
+          <a:p>
+            <a:r>
+              <a:rPr lang="zh-CN" dirty="0"/>
+              <a:t>两者按下标对齐:第 i 个 BufferDesc 描述第 i 个数据块。结构见 buf_internals.h——BufferDesc 含 tag、原子 state、buf_id、content_lock;BufferTag 内嵌 RelFileNode(表空间/库/关系)加 forkNum、blockNum,正是哈希表的查找键。</a:t>
+            </a:r>
+          </a:p>
+          <a:p>
+            <a:r>
+              <a:rPr lang="zh-CN" dirty="0"/>
+              <a:t>容量基准:NBuffers 由 GUC shared_buffers 换算而来,是整个缓冲管理的容量基准。</a:t>
             </a:r>
           </a:p>
         </p:txBody>
@@ -3797,7 +2420,20 @@
           <a:lstStyle/>
           <a:p>
             <a:r>
-              <a:t>BufferAlloc 是共享缓冲池的核心入口。先用 INIT_BUFFERTAG 由 (rnode, forkNum, blockNum) 构造 new_tag，再 BufTableHashCode 算出哈希值并据此选定分区锁。retry 标签处调用 BufTableLookup 在共享哈希表中查找：若返回 buf_id&gt;=0 即命中，GetBufferDescriptor 取出描述符、PinBuffer 钉住防止被淘汰，置 *found=TRUE 后返回，避免磁盘 I/O。未命中时进入 for 循环用 StrategyGetBuffer 选一个淘汰受害页；若受害页带 BM_DIRTY 脏标记，需先把它写回(FlushBuffer，此处仍受 double_write 控制，dw_enabled() 为真时走 first_version_dw_single_flush 双写)。腾出后用 BufTableInsert 把 new_tag 映射到该 buf_id；若此刻发现别人已插入同一 tag(返回值&gt;=0)，则放弃本缓冲、按命中处理。BufTableLookup(buf_table.cpp:86) 实际封装 buf_hash_operate&lt;HASH_FIND&gt;，未找到返回 -1。</a:t>
+              <a:rPr lang="zh-CN" dirty="0"/>
+              <a:t>BufferAlloc 是共享缓冲池的核心入口。先用 INIT_BUFFERTAG 由 (rnode, forkNum, blockNum) 构造 new_tag,再 BufTableHashCode 算哈希、选定分区锁。</a:t>
+            </a:r>
+          </a:p>
+          <a:p>
+            <a:r>
+              <a:rPr lang="zh-CN" dirty="0"/>
+              <a:t>查找:BufTableLookup 在哈希表里找,buf_id≥0 即命中——取描述符、PinBuffer 钉住、置 found 返回,省掉磁盘 I/O。未命中则 StrategyGetBuffer 选淘汰页;若带 BM_DIRTY 脏标记,先 FlushBuffer 写回(仍受 double_write 控制)。</a:t>
+            </a:r>
+          </a:p>
+          <a:p>
+            <a:r>
+              <a:rPr lang="zh-CN" dirty="0"/>
+              <a:t>腾出后 BufTableInsert 把 new_tag 映射到 buf_id;若发现别人已插入同一 tag,就放弃本缓冲、按命中处理。BufTableLookup 实为 buf_hash_operate&lt;HASH_FIND&gt;,没找到返回 -1。</a:t>
             </a:r>
           </a:p>
         </p:txBody>
@@ -3867,348 +2503,20 @@
           <a:lstStyle/>
           <a:p>
             <a:r>
-              <a:rPr dirty="0" err="1"/>
-              <a:t>这是一次缓冲读的完整路径：ReadBuffer</a:t>
-            </a:r>
-            <a:r>
-              <a:rPr dirty="0"/>
-              <a:t> </a:t>
-            </a:r>
-            <a:r>
-              <a:rPr dirty="0" err="1"/>
-              <a:t>是面向上层</a:t>
-            </a:r>
-            <a:r>
-              <a:rPr dirty="0"/>
-              <a:t>(</a:t>
-            </a:r>
-            <a:r>
-              <a:rPr dirty="0" err="1"/>
-              <a:t>MAIN_FORKNUM、RBM_NORMAL、默认策略</a:t>
-            </a:r>
-            <a:r>
-              <a:rPr dirty="0"/>
-              <a:t>)</a:t>
-            </a:r>
-            <a:r>
-              <a:rPr dirty="0" err="1"/>
-              <a:t>的简写入口，经</a:t>
-            </a:r>
-            <a:r>
-              <a:rPr dirty="0"/>
-              <a:t> </a:t>
-            </a:r>
-            <a:r>
-              <a:rPr dirty="0" err="1"/>
-              <a:t>ReadBufferExtended</a:t>
-            </a:r>
-            <a:r>
-              <a:rPr dirty="0"/>
-              <a:t> </a:t>
-            </a:r>
-            <a:r>
-              <a:rPr dirty="0" err="1"/>
-              <a:t>汇入</a:t>
-            </a:r>
-            <a:r>
-              <a:rPr dirty="0"/>
-              <a:t> </a:t>
-            </a:r>
-            <a:r>
-              <a:rPr dirty="0" err="1"/>
-              <a:t>ReadBuffer_common，由它统一处理本地</a:t>
-            </a:r>
-            <a:r>
-              <a:rPr dirty="0"/>
-              <a:t>/</a:t>
-            </a:r>
-            <a:r>
-              <a:rPr dirty="0" err="1"/>
-              <a:t>共享缓冲、扩展页</a:t>
-            </a:r>
-            <a:r>
-              <a:rPr dirty="0"/>
-              <a:t>(P_NEW) </a:t>
-            </a:r>
-            <a:r>
-              <a:rPr dirty="0" err="1"/>
-              <a:t>等情况，并调用</a:t>
-            </a:r>
-            <a:r>
-              <a:rPr dirty="0"/>
-              <a:t> </a:t>
-            </a:r>
-            <a:r>
-              <a:rPr dirty="0" err="1"/>
-              <a:t>BufferAlloc</a:t>
-            </a:r>
-            <a:r>
-              <a:rPr dirty="0"/>
-              <a:t>(bufmgr.cpp:2470 处) </a:t>
-            </a:r>
-            <a:r>
-              <a:rPr dirty="0" err="1"/>
-              <a:t>完成分配。BufferAlloc</a:t>
-            </a:r>
-            <a:r>
-              <a:rPr dirty="0"/>
-              <a:t> 先 </a:t>
-            </a:r>
-            <a:r>
-              <a:rPr dirty="0" err="1"/>
-              <a:t>BufTableLookup</a:t>
-            </a:r>
-            <a:r>
-              <a:rPr dirty="0"/>
-              <a:t> </a:t>
-            </a:r>
-            <a:r>
-              <a:rPr dirty="0" err="1"/>
-              <a:t>查哈希表：命中则置</a:t>
-            </a:r>
-            <a:r>
-              <a:rPr dirty="0"/>
-              <a:t> *hit=true </a:t>
-            </a:r>
-            <a:r>
-              <a:rPr dirty="0" err="1"/>
-              <a:t>直接返回，省去</a:t>
-            </a:r>
-            <a:r>
-              <a:rPr dirty="0"/>
-              <a:t> I/</a:t>
-            </a:r>
-            <a:r>
-              <a:rPr dirty="0" err="1"/>
-              <a:t>O；未命中走</a:t>
-            </a:r>
-            <a:r>
-              <a:rPr dirty="0"/>
-              <a:t> </a:t>
-            </a:r>
-            <a:r>
-              <a:rPr dirty="0" err="1"/>
-              <a:t>StrategyGetBuffer</a:t>
-            </a:r>
-            <a:r>
-              <a:rPr dirty="0"/>
-              <a:t> </a:t>
-            </a:r>
-            <a:r>
-              <a:rPr dirty="0" err="1"/>
-              <a:t>选受害页，脏页经</a:t>
-            </a:r>
-            <a:r>
-              <a:rPr dirty="0"/>
-              <a:t> </a:t>
-            </a:r>
-            <a:r>
-              <a:rPr dirty="0" err="1"/>
-              <a:t>FlushBuffer</a:t>
-            </a:r>
-            <a:r>
-              <a:rPr dirty="0"/>
-              <a:t> </a:t>
-            </a:r>
-            <a:r>
-              <a:rPr dirty="0" err="1"/>
-              <a:t>写回，再</a:t>
-            </a:r>
-            <a:r>
-              <a:rPr dirty="0"/>
-              <a:t> </a:t>
-            </a:r>
-            <a:r>
-              <a:rPr dirty="0" err="1"/>
-              <a:t>BufTableInsert</a:t>
-            </a:r>
-            <a:r>
-              <a:rPr dirty="0"/>
-              <a:t> </a:t>
-            </a:r>
-            <a:r>
-              <a:rPr dirty="0" err="1"/>
-              <a:t>登记新</a:t>
-            </a:r>
-            <a:r>
-              <a:rPr dirty="0"/>
-              <a:t> </a:t>
-            </a:r>
-            <a:r>
-              <a:rPr dirty="0" err="1"/>
-              <a:t>tag。最终在</a:t>
-            </a:r>
-            <a:r>
-              <a:rPr dirty="0"/>
-              <a:t> </a:t>
-            </a:r>
-            <a:r>
-              <a:rPr dirty="0" err="1"/>
-              <a:t>ReadBuffer_common_ReadBlock</a:t>
-            </a:r>
-            <a:r>
-              <a:rPr dirty="0"/>
-              <a:t>(bufmgr.cpp:2141) 调 </a:t>
-            </a:r>
-            <a:r>
-              <a:rPr dirty="0" err="1"/>
-              <a:t>smgrread</a:t>
-            </a:r>
-            <a:r>
-              <a:rPr dirty="0"/>
-              <a:t>(</a:t>
-            </a:r>
-            <a:r>
-              <a:rPr dirty="0" err="1"/>
-              <a:t>smgr</a:t>
-            </a:r>
-            <a:r>
-              <a:rPr dirty="0"/>
-              <a:t>, </a:t>
-            </a:r>
-            <a:r>
-              <a:rPr dirty="0" err="1"/>
-              <a:t>forkNum</a:t>
-            </a:r>
-            <a:r>
-              <a:rPr dirty="0"/>
-              <a:t>, </a:t>
-            </a:r>
-            <a:r>
-              <a:rPr dirty="0" err="1"/>
-              <a:t>blockNum</a:t>
-            </a:r>
-            <a:r>
-              <a:rPr dirty="0"/>
-              <a:t>, </a:t>
-            </a:r>
-            <a:r>
-              <a:rPr dirty="0" err="1"/>
-              <a:t>bufBlock</a:t>
-            </a:r>
-            <a:r>
-              <a:rPr dirty="0"/>
-              <a:t>) </a:t>
-            </a:r>
-            <a:r>
-              <a:rPr dirty="0" err="1"/>
-              <a:t>经存储管理器从磁盘把</a:t>
-            </a:r>
-            <a:r>
-              <a:rPr dirty="0"/>
-              <a:t> 8KB </a:t>
-            </a:r>
-            <a:r>
-              <a:rPr dirty="0" err="1"/>
-              <a:t>页读入缓冲块。运维侧：GaussDB</a:t>
-            </a:r>
-            <a:r>
-              <a:rPr dirty="0"/>
-              <a:t> </a:t>
-            </a:r>
-            <a:r>
-              <a:rPr dirty="0" err="1"/>
-              <a:t>文档以告警</a:t>
-            </a:r>
-            <a:r>
-              <a:rPr dirty="0"/>
-              <a:t> ALM-2001050001 </a:t>
-            </a:r>
-            <a:r>
-              <a:rPr dirty="0" err="1"/>
-              <a:t>监控缓冲池命中率偏低；此外开源</a:t>
-            </a:r>
-            <a:r>
-              <a:rPr dirty="0"/>
-              <a:t> </a:t>
-            </a:r>
-            <a:r>
-              <a:rPr dirty="0" err="1"/>
-              <a:t>openGauss</a:t>
-            </a:r>
-            <a:r>
-              <a:rPr dirty="0"/>
-              <a:t> </a:t>
-            </a:r>
-            <a:r>
-              <a:rPr dirty="0" err="1"/>
-              <a:t>确有列存专用缓冲</a:t>
-            </a:r>
-            <a:r>
-              <a:rPr dirty="0"/>
-              <a:t> </a:t>
-            </a:r>
-            <a:r>
-              <a:rPr dirty="0" err="1"/>
-              <a:t>cstore_buffers</a:t>
-            </a:r>
-            <a:r>
-              <a:rPr dirty="0"/>
-              <a:t>(</a:t>
-            </a:r>
-            <a:r>
-              <a:rPr dirty="0" err="1"/>
-              <a:t>独立于行存</a:t>
-            </a:r>
-            <a:r>
-              <a:rPr dirty="0"/>
-              <a:t> </a:t>
-            </a:r>
-            <a:r>
-              <a:rPr dirty="0" err="1"/>
-              <a:t>shared_buffers</a:t>
-            </a:r>
-            <a:r>
-              <a:rPr dirty="0"/>
-              <a:t>)。</a:t>
-            </a:r>
-            <a:r>
-              <a:rPr dirty="0" err="1"/>
-              <a:t>注意"去双写"在开源版被夸大</a:t>
-            </a:r>
-            <a:r>
-              <a:rPr dirty="0"/>
-              <a:t>——</a:t>
-            </a:r>
-            <a:r>
-              <a:rPr dirty="0" err="1"/>
-              <a:t>上图</a:t>
-            </a:r>
-            <a:r>
-              <a:rPr dirty="0"/>
-              <a:t> </a:t>
-            </a:r>
-            <a:r>
-              <a:rPr dirty="0" err="1"/>
-              <a:t>FlushBuffer</a:t>
-            </a:r>
-            <a:r>
-              <a:rPr dirty="0"/>
-              <a:t> </a:t>
-            </a:r>
-            <a:r>
-              <a:rPr dirty="0" err="1"/>
-              <a:t>仍受</a:t>
-            </a:r>
-            <a:r>
-              <a:rPr dirty="0"/>
-              <a:t> </a:t>
-            </a:r>
-            <a:r>
-              <a:rPr dirty="0" err="1"/>
-              <a:t>dw_enabled</a:t>
-            </a:r>
-            <a:r>
-              <a:rPr dirty="0"/>
-              <a:t>() </a:t>
-            </a:r>
-            <a:r>
-              <a:rPr dirty="0" err="1"/>
-              <a:t>双写保护，并非已移除</a:t>
-            </a:r>
-            <a:r>
-              <a:rPr dirty="0"/>
-              <a:t>。</a:t>
+              <a:rPr lang="zh-CN" dirty="0"/>
+              <a:t>这是一次缓冲读的完整路径。ReadBuffer 是面向上层的简写入口(MAIN_FORKNUM、RBM_NORMAL、默认策略),经 ReadBufferExtended 汇入 ReadBuffer_common,统一处理本地/共享缓冲、P_NEW 扩展页,并调 BufferAlloc 分配。</a:t>
+            </a:r>
+          </a:p>
+          <a:p>
+            <a:r>
+              <a:rPr lang="zh-CN" dirty="0"/>
+              <a:t>BufferAlloc 先 BufTableLookup:命中置 hit 直接返回,省 I/O;未命中走 StrategyGetBuffer 选受害页,脏页 FlushBuffer 写回,再 BufTableInsert 登记。最终在 ReadBlock 里 smgrread 把 8KB 页从磁盘读入缓冲块。</a:t>
+            </a:r>
+          </a:p>
+          <a:p>
+            <a:r>
+              <a:rPr lang="zh-CN" dirty="0"/>
+              <a:t>运维侧:GaussDB 用告警 ALM-2001050001 监控命中率偏低;开源 openGauss 确有列存专用 cstore_buffers,独立于行存 shared_buffers。提醒一句:'去双写'被夸大了——FlushBuffer 仍受 dw_enabled() 保护,并未移除。</a:t>
             </a:r>
           </a:p>
         </p:txBody>
@@ -4278,17 +2586,20 @@
           <a:lstStyle/>
           <a:p>
             <a:r>
-              <a:t>这页讲缓冲池满时如何选受害页淘汰。入口 StrategyGetBuffer 先判断是否带 BufferAccessStrategy 策略对象：顺序扫描、VACUUM、批量写这类会污染缓存的操作，用 GetAccessStrategy(freelist.cpp:466) 申请一个小的环形缓冲(ring)，让它们只在自己的 ring 内循环复用少量页，避免冲刷整个 shared_buffers；GetBufferFromRing(:544) 就是从 ring 当前槽取页。</a:t>
-            </a:r>
-          </a:p>
-          <a:p>
-            <a:r>
-              <a:t>普通分配(strategy==NULL)或 ring 取不到页时，进入经典的 clock-sweep 时钟扫描：ClockSweepTick 把时钟指针前进一格，retryLockBufHdr 自旋取该页头锁；若 refcount==0（无人 pin）且不是元数据页、且非脏或后台可刷脏，则命中为可淘汰页，返回前若带策略再 AddBufferToRing 把它登记进环。源码真实逻辑里每次扫描会递减 usage_count（在 ClockSweepTick 内），usage_count 降为 0 才算冷页被淘汰——这就是"时钟"的本质：给每页第二次机会。</a:t>
-            </a:r>
-          </a:p>
-          <a:p>
-            <a:r>
-              <a:t>补充：openGauss 在标准 clock-sweep 之上还叠加了增量检查点的 candidate list（get_buf_from_candidate_list），由后台 pagewriter 预先挑出可淘汰页，这是相对社区 PostgreSQL 的增强，但核心淘汰判据仍是 refcount 与 usage_count。</a:t>
+              <a:rPr lang="zh-CN" dirty="0"/>
+              <a:t>这页讲缓冲池满时怎么选受害页。入口 StrategyGetBuffer 先看有没有 BufferAccessStrategy:顺序扫描、VACUUM、批量写这类会污染缓存的操作,用 GetAccessStrategy 申请一个小环形缓冲 ring,只在自己的 ring 内复用少量页,不冲刷整个 shared_buffers;GetBufferFromRing 就是从 ring 取页。</a:t>
+            </a:r>
+          </a:p>
+          <a:p>
+            <a:r>
+              <a:rPr lang="zh-CN" dirty="0"/>
+              <a:t>普通分配或 ring 取不到时,走经典 clock-sweep:ClockSweepTick 把时钟指针前进一格,自旋取页头锁;若 refcount=0、非元数据页、且非脏或可刷脏,就是可淘汰页。每扫一次递减 usage_count,降到 0 才算冷页淘汰——这就是'时钟'的本质:给每页第二次机会。</a:t>
+            </a:r>
+          </a:p>
+          <a:p>
+            <a:r>
+              <a:rPr lang="zh-CN" dirty="0"/>
+              <a:t>补充:openGauss 在 clock-sweep 之上加了增量检查点的 candidate list,由 pagewriter 预挑淘汰页,是相对社区 PostgreSQL 的增强;但核心判据仍是 refcount 和 usage_count。</a:t>
             </a:r>
           </a:p>
         </p:txBody>
@@ -4358,17 +2669,20 @@
           <a:lstStyle/>
           <a:p>
             <a:r>
-              <a:t>这页讲页引用计数如何在并发下保持无锁高效。每个 BufferDesc 把 refcount、usage_count 和所有标志位压进一个 64 位 state（见 buf_internals.h:42-73）：低 32 位是 refcount（BUF_STATE_GET_REFCOUNT 直接取低 32 位），bits50-53 是 usage_count（BUF_USAGECOUNT_SHIFT=18+32），更高位是 BM_LOCKED(位54)、BM_DIRTY(位55)、BM_VALID(位56)、BM_IO_IN_PROGRESS(位58) 等标志。把这些塞进一个原子字，是为了一次 CAS 同时读改多个字段，避免每次 pin/unpin 都抢头锁自旋。</a:t>
-            </a:r>
-          </a:p>
-          <a:p>
-            <a:r>
-              <a:t>PinBuffer 的逻辑：若本线程私有引用表里没有该页，先用 __sync_add_and_fetch(&amp;buf-&gt;state,1) 原子把 refcount 加 1（refcount&gt;0 即"钉住"该页，clock-sweep 不会选它做受害者）。若发现 BM_LOCKED 已被别人置位（有人正持头锁改状态），就回退这次 +1 并 WaitBufHdrUnlocked 等待后重试。随后在 while 中用 pg_atomic_compare_exchange_u64 把 usage_count 抬高一档（封顶 BM_MAX_USAGE_COUNT），让热页更难被淘汰；result 取自 BM_VALID 位，告诉调用方页数据是否有效。</a:t>
-            </a:r>
-          </a:p>
-          <a:p>
-            <a:r>
-              <a:t>对照：UnpinBuffer(bufmgr.cpp:3963) 反向用 __sync_add_and_fetch(&amp;buf-&gt;state,-1) 原子减 refcount，减到 0 才真正释放、并处理 BM_PIN_COUNT_WAITER 清理等待者。当确实需要独占修改头部状态时，走 LockBufHdr(bufmgr.cpp:7381)：用 pg_atomic_fetch_or_u64 自旋把 BM_LOCKED 置 1（CAS 风格），拿到后才能成块改写 state，UnlockBufHdr 再清位释放。这套"原子 CAS 优先、头锁兜底"的设计是缓冲管理高并发的关键。</a:t>
+              <a:rPr lang="zh-CN" dirty="0"/>
+              <a:t>这页讲页引用计数怎么在并发下做到无锁高效。每个 BufferDesc 把 refcount、usage_count 和所有标志位压进一个 64 位 state:低 32 位是 refcount,中间几位是 usage_count,高位是 BM_LOCKED、BM_DIRTY、BM_VALID、BM_IO_IN_PROGRESS 等。塞进一个原子字,是为了一次 CAS 同时读改多个字段,免得每次 pin/unpin 都抢头锁自旋。</a:t>
+            </a:r>
+          </a:p>
+          <a:p>
+            <a:r>
+              <a:rPr lang="zh-CN" dirty="0"/>
+              <a:t>PinBuffer:私有引用表里没有该页时,先原子把 refcount 加 1(refcount&gt;0 就钉住,clock-sweep 不选它);若发现 BM_LOCKED 已被别人置位,就回退这次 +1、等解锁再重试。随后用 CAS 把 usage_count 抬高一档(封顶),让热页更难淘汰;返回值取自 BM_VALID,告诉调用方数据是否有效。</a:t>
+            </a:r>
+          </a:p>
+          <a:p>
+            <a:r>
+              <a:rPr lang="zh-CN" dirty="0"/>
+              <a:t>对照:UnpinBuffer 反向原子减 refcount,减到 0 才真正释放、处理等待者。确需独占改头部状态时走 LockBufHdr,自旋把 BM_LOCKED 置 1,改完再 UnlockBufHdr 清位。'原子 CAS 优先、头锁兜底'是高并发的关键。</a:t>
             </a:r>
           </a:p>
         </p:txBody>
@@ -8508,6 +6822,11 @@
         </p:txBody>
       </p:sp>
     </p:spTree>
+    <p:extLst>
+      <p:ext uri="{BB962C8B-B14F-4D97-AF65-F5344CB8AC3E}">
+        <p14:creationId xmlns:p14="http://schemas.microsoft.com/office/powerpoint/2010/main" val="4261728354"/>
+      </p:ext>
+    </p:extLst>
   </p:cSld>
   <p:clrMapOvr>
     <a:masterClrMapping/>
@@ -9283,6 +7602,11 @@
         </p:txBody>
       </p:sp>
     </p:spTree>
+    <p:extLst>
+      <p:ext uri="{BB962C8B-B14F-4D97-AF65-F5344CB8AC3E}">
+        <p14:creationId xmlns:p14="http://schemas.microsoft.com/office/powerpoint/2010/main" val="131588984"/>
+      </p:ext>
+    </p:extLst>
   </p:cSld>
   <p:clrMapOvr>
     <a:masterClrMapping/>
@@ -10022,6 +8346,11 @@
         </p:txBody>
       </p:sp>
     </p:spTree>
+    <p:extLst>
+      <p:ext uri="{BB962C8B-B14F-4D97-AF65-F5344CB8AC3E}">
+        <p14:creationId xmlns:p14="http://schemas.microsoft.com/office/powerpoint/2010/main" val="3560369309"/>
+      </p:ext>
+    </p:extLst>
   </p:cSld>
   <p:clrMapOvr>
     <a:masterClrMapping/>
@@ -10776,6 +9105,11 @@
         </p:txBody>
       </p:sp>
     </p:spTree>
+    <p:extLst>
+      <p:ext uri="{BB962C8B-B14F-4D97-AF65-F5344CB8AC3E}">
+        <p14:creationId xmlns:p14="http://schemas.microsoft.com/office/powerpoint/2010/main" val="1715739366"/>
+      </p:ext>
+    </p:extLst>
   </p:cSld>
   <p:clrMapOvr>
     <a:masterClrMapping/>
@@ -11530,6 +9864,11 @@
         </p:txBody>
       </p:sp>
     </p:spTree>
+    <p:extLst>
+      <p:ext uri="{BB962C8B-B14F-4D97-AF65-F5344CB8AC3E}">
+        <p14:creationId xmlns:p14="http://schemas.microsoft.com/office/powerpoint/2010/main" val="2410202149"/>
+      </p:ext>
+    </p:extLst>
   </p:cSld>
   <p:clrMapOvr>
     <a:masterClrMapping/>
@@ -12129,6 +10468,11 @@
         </p:txBody>
       </p:sp>
     </p:spTree>
+    <p:extLst>
+      <p:ext uri="{BB962C8B-B14F-4D97-AF65-F5344CB8AC3E}">
+        <p14:creationId xmlns:p14="http://schemas.microsoft.com/office/powerpoint/2010/main" val="3525849617"/>
+      </p:ext>
+    </p:extLst>
   </p:cSld>
   <p:clrMapOvr>
     <a:masterClrMapping/>
@@ -12865,6 +11209,11 @@
         </p:txBody>
       </p:sp>
     </p:spTree>
+    <p:extLst>
+      <p:ext uri="{BB962C8B-B14F-4D97-AF65-F5344CB8AC3E}">
+        <p14:creationId xmlns:p14="http://schemas.microsoft.com/office/powerpoint/2010/main" val="3631787766"/>
+      </p:ext>
+    </p:extLst>
   </p:cSld>
   <p:clrMapOvr>
     <a:masterClrMapping/>
@@ -13601,6 +11950,11 @@
         </p:txBody>
       </p:sp>
     </p:spTree>
+    <p:extLst>
+      <p:ext uri="{BB962C8B-B14F-4D97-AF65-F5344CB8AC3E}">
+        <p14:creationId xmlns:p14="http://schemas.microsoft.com/office/powerpoint/2010/main" val="3404748244"/>
+      </p:ext>
+    </p:extLst>
   </p:cSld>
   <p:clrMapOvr>
     <a:masterClrMapping/>
@@ -14355,6 +12709,11 @@
         </p:txBody>
       </p:sp>
     </p:spTree>
+    <p:extLst>
+      <p:ext uri="{BB962C8B-B14F-4D97-AF65-F5344CB8AC3E}">
+        <p14:creationId xmlns:p14="http://schemas.microsoft.com/office/powerpoint/2010/main" val="1989730954"/>
+      </p:ext>
+    </p:extLst>
   </p:cSld>
   <p:clrMapOvr>
     <a:masterClrMapping/>
@@ -15870,6 +14229,11 @@
         </p:txBody>
       </p:sp>
     </p:spTree>
+    <p:extLst>
+      <p:ext uri="{BB962C8B-B14F-4D97-AF65-F5344CB8AC3E}">
+        <p14:creationId xmlns:p14="http://schemas.microsoft.com/office/powerpoint/2010/main" val="377676259"/>
+      </p:ext>
+    </p:extLst>
   </p:cSld>
   <p:clrMapOvr>
     <a:masterClrMapping/>
@@ -16723,6 +15087,11 @@
         </p:txBody>
       </p:sp>
     </p:spTree>
+    <p:extLst>
+      <p:ext uri="{BB962C8B-B14F-4D97-AF65-F5344CB8AC3E}">
+        <p14:creationId xmlns:p14="http://schemas.microsoft.com/office/powerpoint/2010/main" val="3272272664"/>
+      </p:ext>
+    </p:extLst>
   </p:cSld>
   <p:clrMapOvr>
     <a:masterClrMapping/>
@@ -17522,6 +15891,11 @@
         </p:txBody>
       </p:sp>
     </p:spTree>
+    <p:extLst>
+      <p:ext uri="{BB962C8B-B14F-4D97-AF65-F5344CB8AC3E}">
+        <p14:creationId xmlns:p14="http://schemas.microsoft.com/office/powerpoint/2010/main" val="3058171719"/>
+      </p:ext>
+    </p:extLst>
   </p:cSld>
   <p:clrMapOvr>
     <a:masterClrMapping/>
@@ -19013,6 +17387,11 @@
         </p:txBody>
       </p:sp>
     </p:spTree>
+    <p:extLst>
+      <p:ext uri="{BB962C8B-B14F-4D97-AF65-F5344CB8AC3E}">
+        <p14:creationId xmlns:p14="http://schemas.microsoft.com/office/powerpoint/2010/main" val="634135955"/>
+      </p:ext>
+    </p:extLst>
   </p:cSld>
   <p:clrMapOvr>
     <a:masterClrMapping/>
@@ -19788,6 +18167,11 @@
         </p:txBody>
       </p:sp>
     </p:spTree>
+    <p:extLst>
+      <p:ext uri="{BB962C8B-B14F-4D97-AF65-F5344CB8AC3E}">
+        <p14:creationId xmlns:p14="http://schemas.microsoft.com/office/powerpoint/2010/main" val="3061746377"/>
+      </p:ext>
+    </p:extLst>
   </p:cSld>
   <p:clrMapOvr>
     <a:masterClrMapping/>
@@ -20763,6 +19147,11 @@
         </p:txBody>
       </p:sp>
     </p:spTree>
+    <p:extLst>
+      <p:ext uri="{BB962C8B-B14F-4D97-AF65-F5344CB8AC3E}">
+        <p14:creationId xmlns:p14="http://schemas.microsoft.com/office/powerpoint/2010/main" val="349497244"/>
+      </p:ext>
+    </p:extLst>
   </p:cSld>
   <p:clrMapOvr>
     <a:masterClrMapping/>
@@ -21517,6 +19906,11 @@
         </p:txBody>
       </p:sp>
     </p:spTree>
+    <p:extLst>
+      <p:ext uri="{BB962C8B-B14F-4D97-AF65-F5344CB8AC3E}">
+        <p14:creationId xmlns:p14="http://schemas.microsoft.com/office/powerpoint/2010/main" val="3978094860"/>
+      </p:ext>
+    </p:extLst>
   </p:cSld>
   <p:clrMapOvr>
     <a:masterClrMapping/>
@@ -22253,6 +20647,11 @@
         </p:txBody>
       </p:sp>
     </p:spTree>
+    <p:extLst>
+      <p:ext uri="{BB962C8B-B14F-4D97-AF65-F5344CB8AC3E}">
+        <p14:creationId xmlns:p14="http://schemas.microsoft.com/office/powerpoint/2010/main" val="3189912080"/>
+      </p:ext>
+    </p:extLst>
   </p:cSld>
   <p:clrMapOvr>
     <a:masterClrMapping/>
@@ -23228,6 +21627,11 @@
         </p:txBody>
       </p:sp>
     </p:spTree>
+    <p:extLst>
+      <p:ext uri="{BB962C8B-B14F-4D97-AF65-F5344CB8AC3E}">
+        <p14:creationId xmlns:p14="http://schemas.microsoft.com/office/powerpoint/2010/main" val="3493790535"/>
+      </p:ext>
+    </p:extLst>
   </p:cSld>
   <p:clrMapOvr>
     <a:masterClrMapping/>
@@ -26455,6 +24859,11 @@
         </p:txBody>
       </p:sp>
     </p:spTree>
+    <p:extLst>
+      <p:ext uri="{BB962C8B-B14F-4D97-AF65-F5344CB8AC3E}">
+        <p14:creationId xmlns:p14="http://schemas.microsoft.com/office/powerpoint/2010/main" val="105261781"/>
+      </p:ext>
+    </p:extLst>
   </p:cSld>
   <p:clrMapOvr>
     <a:masterClrMapping/>
@@ -26881,6 +25290,11 @@
         </p:txBody>
       </p:sp>
     </p:spTree>
+    <p:extLst>
+      <p:ext uri="{BB962C8B-B14F-4D97-AF65-F5344CB8AC3E}">
+        <p14:creationId xmlns:p14="http://schemas.microsoft.com/office/powerpoint/2010/main" val="1161919812"/>
+      </p:ext>
+    </p:extLst>
   </p:cSld>
   <p:clrMapOvr>
     <a:masterClrMapping/>
@@ -27909,6 +26323,11 @@
         </p:style>
       </p:cxnSp>
     </p:spTree>
+    <p:extLst>
+      <p:ext uri="{BB962C8B-B14F-4D97-AF65-F5344CB8AC3E}">
+        <p14:creationId xmlns:p14="http://schemas.microsoft.com/office/powerpoint/2010/main" val="4257652468"/>
+      </p:ext>
+    </p:extLst>
   </p:cSld>
   <p:clrMapOvr>
     <a:masterClrMapping/>
@@ -29052,6 +27471,11 @@
         </p:txBody>
       </p:sp>
     </p:spTree>
+    <p:extLst>
+      <p:ext uri="{BB962C8B-B14F-4D97-AF65-F5344CB8AC3E}">
+        <p14:creationId xmlns:p14="http://schemas.microsoft.com/office/powerpoint/2010/main" val="4271988537"/>
+      </p:ext>
+    </p:extLst>
   </p:cSld>
   <p:clrMapOvr>
     <a:masterClrMapping/>
@@ -30667,6 +29091,11 @@
         </p:txBody>
       </p:sp>
     </p:spTree>
+    <p:extLst>
+      <p:ext uri="{BB962C8B-B14F-4D97-AF65-F5344CB8AC3E}">
+        <p14:creationId xmlns:p14="http://schemas.microsoft.com/office/powerpoint/2010/main" val="2313155927"/>
+      </p:ext>
+    </p:extLst>
   </p:cSld>
   <p:clrMapOvr>
     <a:masterClrMapping/>
@@ -31424,6 +29853,11 @@
         </p:txBody>
       </p:sp>
     </p:spTree>
+    <p:extLst>
+      <p:ext uri="{BB962C8B-B14F-4D97-AF65-F5344CB8AC3E}">
+        <p14:creationId xmlns:p14="http://schemas.microsoft.com/office/powerpoint/2010/main" val="2542826156"/>
+      </p:ext>
+    </p:extLst>
   </p:cSld>
   <p:clrMapOvr>
     <a:masterClrMapping/>
@@ -32502,6 +30936,11 @@
         </p:txBody>
       </p:sp>
     </p:spTree>
+    <p:extLst>
+      <p:ext uri="{BB962C8B-B14F-4D97-AF65-F5344CB8AC3E}">
+        <p14:creationId xmlns:p14="http://schemas.microsoft.com/office/powerpoint/2010/main" val="974417844"/>
+      </p:ext>
+    </p:extLst>
   </p:cSld>
   <p:clrMapOvr>
     <a:masterClrMapping/>
@@ -34097,6 +32536,11 @@
         </p:style>
       </p:cxnSp>
     </p:spTree>
+    <p:extLst>
+      <p:ext uri="{BB962C8B-B14F-4D97-AF65-F5344CB8AC3E}">
+        <p14:creationId xmlns:p14="http://schemas.microsoft.com/office/powerpoint/2010/main" val="1315669839"/>
+      </p:ext>
+    </p:extLst>
   </p:cSld>
   <p:clrMapOvr>
     <a:masterClrMapping/>
@@ -35279,6 +33723,11 @@
         </p:txBody>
       </p:sp>
     </p:spTree>
+    <p:extLst>
+      <p:ext uri="{BB962C8B-B14F-4D97-AF65-F5344CB8AC3E}">
+        <p14:creationId xmlns:p14="http://schemas.microsoft.com/office/powerpoint/2010/main" val="1992291707"/>
+      </p:ext>
+    </p:extLst>
   </p:cSld>
   <p:clrMapOvr>
     <a:masterClrMapping/>

</xml_diff>